<commit_message>
Include actual web demo screenshot and reproducible LMS package helper
</commit_message>
<xml_diff>
--- a/reports/PhamDangQuang_final.pptx
+++ b/reports/PhamDangQuang_final.pptx
@@ -211,7 +211,7 @@
             </a:lvl1pPr>
           </a:lstStyle>
           <a:p>
-            <a:fld id="{CC072EF8-8C95-4E28-ADD0-6A00F3345142}" type="datetimeFigureOut">
+            <a:fld id="{62829297-CBFC-4239-83DA-BC875376E9F8}" type="datetimeFigureOut">
               <a:rPr lang="en-US" smtClean="0"/>
               <a:t>10/5/2026</a:t>
             </a:fld>
@@ -369,7 +369,7 @@
             </a:lvl1pPr>
           </a:lstStyle>
           <a:p>
-            <a:fld id="{3701041B-C843-4930-8465-9FD0C8B7AE63}" type="slidenum">
+            <a:fld id="{12B22E93-A396-4114-B21C-8A67817DF507}" type="slidenum">
               <a:rPr lang="en-US" smtClean="0"/>
               <a:t>‹#›</a:t>
             </a:fld>
@@ -380,7 +380,7 @@
     </p:spTree>
     <p:extLst>
       <p:ext uri="{BB962C8B-B14F-4D97-AF65-F5344CB8AC3E}">
-        <p14:creationId xmlns:p14="http://schemas.microsoft.com/office/powerpoint/2010/main" val="1680954674"/>
+        <p14:creationId xmlns:p14="http://schemas.microsoft.com/office/powerpoint/2010/main" val="2963266890"/>
       </p:ext>
     </p:extLst>
   </p:cSld>
@@ -547,7 +547,7 @@
           <a:bodyPr/>
           <a:lstStyle/>
           <a:p>
-            <a:fld id="{3701041B-C843-4930-8465-9FD0C8B7AE63}" type="slidenum">
+            <a:fld id="{12B22E93-A396-4114-B21C-8A67817DF507}" type="slidenum">
               <a:rPr lang="en-US" smtClean="0"/>
               <a:t>2</a:t>
             </a:fld>
@@ -558,7 +558,7 @@
     </p:spTree>
     <p:extLst>
       <p:ext uri="{BB962C8B-B14F-4D97-AF65-F5344CB8AC3E}">
-        <p14:creationId xmlns:p14="http://schemas.microsoft.com/office/powerpoint/2010/main" val="3268124437"/>
+        <p14:creationId xmlns:p14="http://schemas.microsoft.com/office/powerpoint/2010/main" val="1747857678"/>
       </p:ext>
     </p:extLst>
   </p:cSld>
@@ -634,7 +634,7 @@
           <a:bodyPr/>
           <a:lstStyle/>
           <a:p>
-            <a:fld id="{3701041B-C843-4930-8465-9FD0C8B7AE63}" type="slidenum">
+            <a:fld id="{12B22E93-A396-4114-B21C-8A67817DF507}" type="slidenum">
               <a:rPr lang="en-US" smtClean="0"/>
               <a:t>11</a:t>
             </a:fld>
@@ -645,7 +645,7 @@
     </p:spTree>
     <p:extLst>
       <p:ext uri="{BB962C8B-B14F-4D97-AF65-F5344CB8AC3E}">
-        <p14:creationId xmlns:p14="http://schemas.microsoft.com/office/powerpoint/2010/main" val="4093140818"/>
+        <p14:creationId xmlns:p14="http://schemas.microsoft.com/office/powerpoint/2010/main" val="1324044069"/>
       </p:ext>
     </p:extLst>
   </p:cSld>
@@ -722,7 +722,7 @@
           <a:bodyPr/>
           <a:lstStyle/>
           <a:p>
-            <a:fld id="{3701041B-C843-4930-8465-9FD0C8B7AE63}" type="slidenum">
+            <a:fld id="{12B22E93-A396-4114-B21C-8A67817DF507}" type="slidenum">
               <a:rPr lang="en-US" smtClean="0"/>
               <a:t>12</a:t>
             </a:fld>
@@ -733,7 +733,7 @@
     </p:spTree>
     <p:extLst>
       <p:ext uri="{BB962C8B-B14F-4D97-AF65-F5344CB8AC3E}">
-        <p14:creationId xmlns:p14="http://schemas.microsoft.com/office/powerpoint/2010/main" val="991072443"/>
+        <p14:creationId xmlns:p14="http://schemas.microsoft.com/office/powerpoint/2010/main" val="4168997133"/>
       </p:ext>
     </p:extLst>
   </p:cSld>
@@ -809,7 +809,7 @@
           <a:bodyPr/>
           <a:lstStyle/>
           <a:p>
-            <a:fld id="{3701041B-C843-4930-8465-9FD0C8B7AE63}" type="slidenum">
+            <a:fld id="{12B22E93-A396-4114-B21C-8A67817DF507}" type="slidenum">
               <a:rPr lang="en-US" smtClean="0"/>
               <a:t>13</a:t>
             </a:fld>
@@ -820,7 +820,7 @@
     </p:spTree>
     <p:extLst>
       <p:ext uri="{BB962C8B-B14F-4D97-AF65-F5344CB8AC3E}">
-        <p14:creationId xmlns:p14="http://schemas.microsoft.com/office/powerpoint/2010/main" val="566927789"/>
+        <p14:creationId xmlns:p14="http://schemas.microsoft.com/office/powerpoint/2010/main" val="1381523981"/>
       </p:ext>
     </p:extLst>
   </p:cSld>
@@ -896,7 +896,7 @@
           <a:bodyPr/>
           <a:lstStyle/>
           <a:p>
-            <a:fld id="{3701041B-C843-4930-8465-9FD0C8B7AE63}" type="slidenum">
+            <a:fld id="{12B22E93-A396-4114-B21C-8A67817DF507}" type="slidenum">
               <a:rPr lang="en-US" smtClean="0"/>
               <a:t>14</a:t>
             </a:fld>
@@ -907,7 +907,7 @@
     </p:spTree>
     <p:extLst>
       <p:ext uri="{BB962C8B-B14F-4D97-AF65-F5344CB8AC3E}">
-        <p14:creationId xmlns:p14="http://schemas.microsoft.com/office/powerpoint/2010/main" val="2500865661"/>
+        <p14:creationId xmlns:p14="http://schemas.microsoft.com/office/powerpoint/2010/main" val="3996207522"/>
       </p:ext>
     </p:extLst>
   </p:cSld>
@@ -991,7 +991,7 @@
           <a:bodyPr/>
           <a:lstStyle/>
           <a:p>
-            <a:fld id="{3701041B-C843-4930-8465-9FD0C8B7AE63}" type="slidenum">
+            <a:fld id="{12B22E93-A396-4114-B21C-8A67817DF507}" type="slidenum">
               <a:rPr lang="en-US" smtClean="0"/>
               <a:t>15</a:t>
             </a:fld>
@@ -1002,7 +1002,7 @@
     </p:spTree>
     <p:extLst>
       <p:ext uri="{BB962C8B-B14F-4D97-AF65-F5344CB8AC3E}">
-        <p14:creationId xmlns:p14="http://schemas.microsoft.com/office/powerpoint/2010/main" val="3361893319"/>
+        <p14:creationId xmlns:p14="http://schemas.microsoft.com/office/powerpoint/2010/main" val="625762596"/>
       </p:ext>
     </p:extLst>
   </p:cSld>
@@ -1078,7 +1078,7 @@
           <a:bodyPr/>
           <a:lstStyle/>
           <a:p>
-            <a:fld id="{3701041B-C843-4930-8465-9FD0C8B7AE63}" type="slidenum">
+            <a:fld id="{12B22E93-A396-4114-B21C-8A67817DF507}" type="slidenum">
               <a:rPr lang="en-US" smtClean="0"/>
               <a:t>16</a:t>
             </a:fld>
@@ -1089,7 +1089,7 @@
     </p:spTree>
     <p:extLst>
       <p:ext uri="{BB962C8B-B14F-4D97-AF65-F5344CB8AC3E}">
-        <p14:creationId xmlns:p14="http://schemas.microsoft.com/office/powerpoint/2010/main" val="3041935644"/>
+        <p14:creationId xmlns:p14="http://schemas.microsoft.com/office/powerpoint/2010/main" val="2788914559"/>
       </p:ext>
     </p:extLst>
   </p:cSld>
@@ -1165,7 +1165,7 @@
           <a:bodyPr/>
           <a:lstStyle/>
           <a:p>
-            <a:fld id="{3701041B-C843-4930-8465-9FD0C8B7AE63}" type="slidenum">
+            <a:fld id="{12B22E93-A396-4114-B21C-8A67817DF507}" type="slidenum">
               <a:rPr lang="en-US" smtClean="0"/>
               <a:t>17</a:t>
             </a:fld>
@@ -1176,7 +1176,7 @@
     </p:spTree>
     <p:extLst>
       <p:ext uri="{BB962C8B-B14F-4D97-AF65-F5344CB8AC3E}">
-        <p14:creationId xmlns:p14="http://schemas.microsoft.com/office/powerpoint/2010/main" val="4069548095"/>
+        <p14:creationId xmlns:p14="http://schemas.microsoft.com/office/powerpoint/2010/main" val="2218553933"/>
       </p:ext>
     </p:extLst>
   </p:cSld>
@@ -1232,7 +1232,7 @@
           <a:p>
             <a:r>
               <a:rPr lang="en-US"/>
-              <a:t>Nguồn: web/index.html, web/app.js, src/ppg_cvae/web.py. Chạy scripts/start_web.ps1. Có thể bổ sung ảnh chụp giao diện theo reports/HUONG_DAN_BO_SUNG_ANH_WEB.md.</a:t>
+              <a:t>Nguồn: web/index.html, web/app.js, src/ppg_cvae/web.py. Chạy scripts/start_web.ps1. Có thể bổ sung ảnh chụp giao diện theo reports/HUONG_DAN_BO_SUNG_ANH_WEB.md. Image source: interface screenshot already inserted in the student report, figure 19.</a:t>
             </a:r>
           </a:p>
         </p:txBody>
@@ -1252,7 +1252,7 @@
           <a:bodyPr/>
           <a:lstStyle/>
           <a:p>
-            <a:fld id="{3701041B-C843-4930-8465-9FD0C8B7AE63}" type="slidenum">
+            <a:fld id="{12B22E93-A396-4114-B21C-8A67817DF507}" type="slidenum">
               <a:rPr lang="en-US" smtClean="0"/>
               <a:t>18</a:t>
             </a:fld>
@@ -1263,7 +1263,7 @@
     </p:spTree>
     <p:extLst>
       <p:ext uri="{BB962C8B-B14F-4D97-AF65-F5344CB8AC3E}">
-        <p14:creationId xmlns:p14="http://schemas.microsoft.com/office/powerpoint/2010/main" val="3146063865"/>
+        <p14:creationId xmlns:p14="http://schemas.microsoft.com/office/powerpoint/2010/main" val="878360456"/>
       </p:ext>
     </p:extLst>
   </p:cSld>
@@ -1339,7 +1339,7 @@
           <a:bodyPr/>
           <a:lstStyle/>
           <a:p>
-            <a:fld id="{3701041B-C843-4930-8465-9FD0C8B7AE63}" type="slidenum">
+            <a:fld id="{12B22E93-A396-4114-B21C-8A67817DF507}" type="slidenum">
               <a:rPr lang="en-US" smtClean="0"/>
               <a:t>19</a:t>
             </a:fld>
@@ -1350,7 +1350,7 @@
     </p:spTree>
     <p:extLst>
       <p:ext uri="{BB962C8B-B14F-4D97-AF65-F5344CB8AC3E}">
-        <p14:creationId xmlns:p14="http://schemas.microsoft.com/office/powerpoint/2010/main" val="3400422213"/>
+        <p14:creationId xmlns:p14="http://schemas.microsoft.com/office/powerpoint/2010/main" val="807725938"/>
       </p:ext>
     </p:extLst>
   </p:cSld>
@@ -1427,7 +1427,7 @@
           <a:bodyPr/>
           <a:lstStyle/>
           <a:p>
-            <a:fld id="{3701041B-C843-4930-8465-9FD0C8B7AE63}" type="slidenum">
+            <a:fld id="{12B22E93-A396-4114-B21C-8A67817DF507}" type="slidenum">
               <a:rPr lang="en-US" smtClean="0"/>
               <a:t>20</a:t>
             </a:fld>
@@ -1438,7 +1438,7 @@
     </p:spTree>
     <p:extLst>
       <p:ext uri="{BB962C8B-B14F-4D97-AF65-F5344CB8AC3E}">
-        <p14:creationId xmlns:p14="http://schemas.microsoft.com/office/powerpoint/2010/main" val="443433813"/>
+        <p14:creationId xmlns:p14="http://schemas.microsoft.com/office/powerpoint/2010/main" val="4170164413"/>
       </p:ext>
     </p:extLst>
   </p:cSld>
@@ -1514,7 +1514,7 @@
           <a:bodyPr/>
           <a:lstStyle/>
           <a:p>
-            <a:fld id="{3701041B-C843-4930-8465-9FD0C8B7AE63}" type="slidenum">
+            <a:fld id="{12B22E93-A396-4114-B21C-8A67817DF507}" type="slidenum">
               <a:rPr lang="en-US" smtClean="0"/>
               <a:t>3</a:t>
             </a:fld>
@@ -1525,7 +1525,7 @@
     </p:spTree>
     <p:extLst>
       <p:ext uri="{BB962C8B-B14F-4D97-AF65-F5344CB8AC3E}">
-        <p14:creationId xmlns:p14="http://schemas.microsoft.com/office/powerpoint/2010/main" val="1089407894"/>
+        <p14:creationId xmlns:p14="http://schemas.microsoft.com/office/powerpoint/2010/main" val="3108765869"/>
       </p:ext>
     </p:extLst>
   </p:cSld>
@@ -1602,7 +1602,7 @@
           <a:bodyPr/>
           <a:lstStyle/>
           <a:p>
-            <a:fld id="{3701041B-C843-4930-8465-9FD0C8B7AE63}" type="slidenum">
+            <a:fld id="{12B22E93-A396-4114-B21C-8A67817DF507}" type="slidenum">
               <a:rPr lang="en-US" smtClean="0"/>
               <a:t>21</a:t>
             </a:fld>
@@ -1613,7 +1613,7 @@
     </p:spTree>
     <p:extLst>
       <p:ext uri="{BB962C8B-B14F-4D97-AF65-F5344CB8AC3E}">
-        <p14:creationId xmlns:p14="http://schemas.microsoft.com/office/powerpoint/2010/main" val="3415740877"/>
+        <p14:creationId xmlns:p14="http://schemas.microsoft.com/office/powerpoint/2010/main" val="3533294675"/>
       </p:ext>
     </p:extLst>
   </p:cSld>
@@ -1690,7 +1690,7 @@
           <a:bodyPr/>
           <a:lstStyle/>
           <a:p>
-            <a:fld id="{3701041B-C843-4930-8465-9FD0C8B7AE63}" type="slidenum">
+            <a:fld id="{12B22E93-A396-4114-B21C-8A67817DF507}" type="slidenum">
               <a:rPr lang="en-US" smtClean="0"/>
               <a:t>4</a:t>
             </a:fld>
@@ -1701,7 +1701,7 @@
     </p:spTree>
     <p:extLst>
       <p:ext uri="{BB962C8B-B14F-4D97-AF65-F5344CB8AC3E}">
-        <p14:creationId xmlns:p14="http://schemas.microsoft.com/office/powerpoint/2010/main" val="2868978945"/>
+        <p14:creationId xmlns:p14="http://schemas.microsoft.com/office/powerpoint/2010/main" val="3205311229"/>
       </p:ext>
     </p:extLst>
   </p:cSld>
@@ -1778,7 +1778,7 @@
           <a:bodyPr/>
           <a:lstStyle/>
           <a:p>
-            <a:fld id="{3701041B-C843-4930-8465-9FD0C8B7AE63}" type="slidenum">
+            <a:fld id="{12B22E93-A396-4114-B21C-8A67817DF507}" type="slidenum">
               <a:rPr lang="en-US" smtClean="0"/>
               <a:t>5</a:t>
             </a:fld>
@@ -1789,7 +1789,7 @@
     </p:spTree>
     <p:extLst>
       <p:ext uri="{BB962C8B-B14F-4D97-AF65-F5344CB8AC3E}">
-        <p14:creationId xmlns:p14="http://schemas.microsoft.com/office/powerpoint/2010/main" val="2162615920"/>
+        <p14:creationId xmlns:p14="http://schemas.microsoft.com/office/powerpoint/2010/main" val="1559561751"/>
       </p:ext>
     </p:extLst>
   </p:cSld>
@@ -1865,7 +1865,7 @@
           <a:bodyPr/>
           <a:lstStyle/>
           <a:p>
-            <a:fld id="{3701041B-C843-4930-8465-9FD0C8B7AE63}" type="slidenum">
+            <a:fld id="{12B22E93-A396-4114-B21C-8A67817DF507}" type="slidenum">
               <a:rPr lang="en-US" smtClean="0"/>
               <a:t>6</a:t>
             </a:fld>
@@ -1876,7 +1876,7 @@
     </p:spTree>
     <p:extLst>
       <p:ext uri="{BB962C8B-B14F-4D97-AF65-F5344CB8AC3E}">
-        <p14:creationId xmlns:p14="http://schemas.microsoft.com/office/powerpoint/2010/main" val="3639415555"/>
+        <p14:creationId xmlns:p14="http://schemas.microsoft.com/office/powerpoint/2010/main" val="1088960809"/>
       </p:ext>
     </p:extLst>
   </p:cSld>
@@ -1952,7 +1952,7 @@
           <a:bodyPr/>
           <a:lstStyle/>
           <a:p>
-            <a:fld id="{3701041B-C843-4930-8465-9FD0C8B7AE63}" type="slidenum">
+            <a:fld id="{12B22E93-A396-4114-B21C-8A67817DF507}" type="slidenum">
               <a:rPr lang="en-US" smtClean="0"/>
               <a:t>7</a:t>
             </a:fld>
@@ -1963,7 +1963,7 @@
     </p:spTree>
     <p:extLst>
       <p:ext uri="{BB962C8B-B14F-4D97-AF65-F5344CB8AC3E}">
-        <p14:creationId xmlns:p14="http://schemas.microsoft.com/office/powerpoint/2010/main" val="492041447"/>
+        <p14:creationId xmlns:p14="http://schemas.microsoft.com/office/powerpoint/2010/main" val="1389192729"/>
       </p:ext>
     </p:extLst>
   </p:cSld>
@@ -2039,7 +2039,7 @@
           <a:bodyPr/>
           <a:lstStyle/>
           <a:p>
-            <a:fld id="{3701041B-C843-4930-8465-9FD0C8B7AE63}" type="slidenum">
+            <a:fld id="{12B22E93-A396-4114-B21C-8A67817DF507}" type="slidenum">
               <a:rPr lang="en-US" smtClean="0"/>
               <a:t>8</a:t>
             </a:fld>
@@ -2050,7 +2050,7 @@
     </p:spTree>
     <p:extLst>
       <p:ext uri="{BB962C8B-B14F-4D97-AF65-F5344CB8AC3E}">
-        <p14:creationId xmlns:p14="http://schemas.microsoft.com/office/powerpoint/2010/main" val="423351868"/>
+        <p14:creationId xmlns:p14="http://schemas.microsoft.com/office/powerpoint/2010/main" val="112066117"/>
       </p:ext>
     </p:extLst>
   </p:cSld>
@@ -2126,7 +2126,7 @@
           <a:bodyPr/>
           <a:lstStyle/>
           <a:p>
-            <a:fld id="{3701041B-C843-4930-8465-9FD0C8B7AE63}" type="slidenum">
+            <a:fld id="{12B22E93-A396-4114-B21C-8A67817DF507}" type="slidenum">
               <a:rPr lang="en-US" smtClean="0"/>
               <a:t>9</a:t>
             </a:fld>
@@ -2137,7 +2137,7 @@
     </p:spTree>
     <p:extLst>
       <p:ext uri="{BB962C8B-B14F-4D97-AF65-F5344CB8AC3E}">
-        <p14:creationId xmlns:p14="http://schemas.microsoft.com/office/powerpoint/2010/main" val="661508577"/>
+        <p14:creationId xmlns:p14="http://schemas.microsoft.com/office/powerpoint/2010/main" val="2237975111"/>
       </p:ext>
     </p:extLst>
   </p:cSld>
@@ -2213,7 +2213,7 @@
           <a:bodyPr/>
           <a:lstStyle/>
           <a:p>
-            <a:fld id="{3701041B-C843-4930-8465-9FD0C8B7AE63}" type="slidenum">
+            <a:fld id="{12B22E93-A396-4114-B21C-8A67817DF507}" type="slidenum">
               <a:rPr lang="en-US" smtClean="0"/>
               <a:t>10</a:t>
             </a:fld>
@@ -2224,7 +2224,7 @@
     </p:spTree>
     <p:extLst>
       <p:ext uri="{BB962C8B-B14F-4D97-AF65-F5344CB8AC3E}">
-        <p14:creationId xmlns:p14="http://schemas.microsoft.com/office/powerpoint/2010/main" val="2095325093"/>
+        <p14:creationId xmlns:p14="http://schemas.microsoft.com/office/powerpoint/2010/main" val="3694937420"/>
       </p:ext>
     </p:extLst>
   </p:cSld>
@@ -2256,7 +2256,7 @@
           <p:cNvPr id="2" name="Title 1">
             <a:extLst>
               <a:ext uri="{FF2B5EF4-FFF2-40B4-BE49-F238E27FC236}">
-                <a16:creationId xmlns:a16="http://schemas.microsoft.com/office/drawing/2014/main" id="{BB441500-30F9-EA47-0440-15B450ADEB38}"/>
+                <a16:creationId xmlns:a16="http://schemas.microsoft.com/office/drawing/2014/main" id="{C2E8A8DB-A55D-5FE3-A367-CE7A0DC68687}"/>
               </a:ext>
             </a:extLst>
           </p:cNvPr>
@@ -2293,7 +2293,7 @@
           <p:cNvPr id="3" name="Subtitle 2">
             <a:extLst>
               <a:ext uri="{FF2B5EF4-FFF2-40B4-BE49-F238E27FC236}">
-                <a16:creationId xmlns:a16="http://schemas.microsoft.com/office/drawing/2014/main" id="{471F7358-688F-B399-5D73-E3247D63ED09}"/>
+                <a16:creationId xmlns:a16="http://schemas.microsoft.com/office/drawing/2014/main" id="{E40F8558-35D7-5378-D00D-E00ED3079447}"/>
               </a:ext>
             </a:extLst>
           </p:cNvPr>
@@ -2363,7 +2363,7 @@
           <p:cNvPr id="4" name="Date Placeholder 3">
             <a:extLst>
               <a:ext uri="{FF2B5EF4-FFF2-40B4-BE49-F238E27FC236}">
-                <a16:creationId xmlns:a16="http://schemas.microsoft.com/office/drawing/2014/main" id="{33FAE2F8-1A17-3A03-BC0A-3D3120E6A05A}"/>
+                <a16:creationId xmlns:a16="http://schemas.microsoft.com/office/drawing/2014/main" id="{4C1EDFED-DDE0-E203-B244-08732863DF00}"/>
               </a:ext>
             </a:extLst>
           </p:cNvPr>
@@ -2379,7 +2379,7 @@
           <a:bodyPr/>
           <a:lstStyle/>
           <a:p>
-            <a:fld id="{CC7F535A-4247-4CDB-B883-63B688F24BAB}" type="datetimeFigureOut">
+            <a:fld id="{C2ECBD91-BFAB-4C42-B9B2-6A9A807B9942}" type="datetimeFigureOut">
               <a:rPr lang="en-US" smtClean="0"/>
               <a:t>10/5/2026</a:t>
             </a:fld>
@@ -2392,7 +2392,7 @@
           <p:cNvPr id="5" name="Footer Placeholder 4">
             <a:extLst>
               <a:ext uri="{FF2B5EF4-FFF2-40B4-BE49-F238E27FC236}">
-                <a16:creationId xmlns:a16="http://schemas.microsoft.com/office/drawing/2014/main" id="{0860EE98-1CEA-73BC-62E2-626DCF67E1F0}"/>
+                <a16:creationId xmlns:a16="http://schemas.microsoft.com/office/drawing/2014/main" id="{BC23F05B-DDDF-881F-51E6-DD8BEE27DF1A}"/>
               </a:ext>
             </a:extLst>
           </p:cNvPr>
@@ -2417,7 +2417,7 @@
           <p:cNvPr id="6" name="Slide Number Placeholder 5">
             <a:extLst>
               <a:ext uri="{FF2B5EF4-FFF2-40B4-BE49-F238E27FC236}">
-                <a16:creationId xmlns:a16="http://schemas.microsoft.com/office/drawing/2014/main" id="{8D2595AF-9330-3753-438A-1E194485191F}"/>
+                <a16:creationId xmlns:a16="http://schemas.microsoft.com/office/drawing/2014/main" id="{12E99084-836F-D070-BAD7-3DF4F32B11FD}"/>
               </a:ext>
             </a:extLst>
           </p:cNvPr>
@@ -2433,7 +2433,7 @@
           <a:bodyPr/>
           <a:lstStyle/>
           <a:p>
-            <a:fld id="{645D0087-1160-4B24-BE86-FBB568D75C7A}" type="slidenum">
+            <a:fld id="{C82F3021-0F90-4978-9EEE-C3024DCBA810}" type="slidenum">
               <a:rPr lang="en-US" smtClean="0"/>
               <a:t>‹#›</a:t>
             </a:fld>
@@ -2444,7 +2444,7 @@
     </p:spTree>
     <p:extLst>
       <p:ext uri="{BB962C8B-B14F-4D97-AF65-F5344CB8AC3E}">
-        <p14:creationId xmlns:p14="http://schemas.microsoft.com/office/powerpoint/2010/main" val="1923060687"/>
+        <p14:creationId xmlns:p14="http://schemas.microsoft.com/office/powerpoint/2010/main" val="1036781463"/>
       </p:ext>
     </p:extLst>
   </p:cSld>
@@ -2476,7 +2476,7 @@
           <p:cNvPr id="2" name="Title 1">
             <a:extLst>
               <a:ext uri="{FF2B5EF4-FFF2-40B4-BE49-F238E27FC236}">
-                <a16:creationId xmlns:a16="http://schemas.microsoft.com/office/drawing/2014/main" id="{1202FD1E-8237-7D0D-ABD8-7841DDE295F5}"/>
+                <a16:creationId xmlns:a16="http://schemas.microsoft.com/office/drawing/2014/main" id="{23D9C2DB-A1B8-7608-1F50-9CC2EDA58C96}"/>
               </a:ext>
             </a:extLst>
           </p:cNvPr>
@@ -2504,7 +2504,7 @@
           <p:cNvPr id="3" name="Vertical Text Placeholder 2">
             <a:extLst>
               <a:ext uri="{FF2B5EF4-FFF2-40B4-BE49-F238E27FC236}">
-                <a16:creationId xmlns:a16="http://schemas.microsoft.com/office/drawing/2014/main" id="{08CFDA57-B435-AE12-53A0-A55CDDF5EFBC}"/>
+                <a16:creationId xmlns:a16="http://schemas.microsoft.com/office/drawing/2014/main" id="{9929FBA7-C768-A97C-6A07-EC568065359C}"/>
               </a:ext>
             </a:extLst>
           </p:cNvPr>
@@ -2561,7 +2561,7 @@
           <p:cNvPr id="4" name="Date Placeholder 3">
             <a:extLst>
               <a:ext uri="{FF2B5EF4-FFF2-40B4-BE49-F238E27FC236}">
-                <a16:creationId xmlns:a16="http://schemas.microsoft.com/office/drawing/2014/main" id="{2D198CDF-B376-6608-139F-942F48086022}"/>
+                <a16:creationId xmlns:a16="http://schemas.microsoft.com/office/drawing/2014/main" id="{1CBEEB30-A97A-CBF6-695E-070D522AA0D3}"/>
               </a:ext>
             </a:extLst>
           </p:cNvPr>
@@ -2577,7 +2577,7 @@
           <a:bodyPr/>
           <a:lstStyle/>
           <a:p>
-            <a:fld id="{CC7F535A-4247-4CDB-B883-63B688F24BAB}" type="datetimeFigureOut">
+            <a:fld id="{C2ECBD91-BFAB-4C42-B9B2-6A9A807B9942}" type="datetimeFigureOut">
               <a:rPr lang="en-US" smtClean="0"/>
               <a:t>10/5/2026</a:t>
             </a:fld>
@@ -2590,7 +2590,7 @@
           <p:cNvPr id="5" name="Footer Placeholder 4">
             <a:extLst>
               <a:ext uri="{FF2B5EF4-FFF2-40B4-BE49-F238E27FC236}">
-                <a16:creationId xmlns:a16="http://schemas.microsoft.com/office/drawing/2014/main" id="{33625CED-4186-81C7-2775-1FC2931CBF83}"/>
+                <a16:creationId xmlns:a16="http://schemas.microsoft.com/office/drawing/2014/main" id="{7F7F19B8-E2DE-D674-7574-637E37AD7A31}"/>
               </a:ext>
             </a:extLst>
           </p:cNvPr>
@@ -2615,7 +2615,7 @@
           <p:cNvPr id="6" name="Slide Number Placeholder 5">
             <a:extLst>
               <a:ext uri="{FF2B5EF4-FFF2-40B4-BE49-F238E27FC236}">
-                <a16:creationId xmlns:a16="http://schemas.microsoft.com/office/drawing/2014/main" id="{03B98E06-B24F-E6F3-FB43-983CFBA6C644}"/>
+                <a16:creationId xmlns:a16="http://schemas.microsoft.com/office/drawing/2014/main" id="{FCB3E824-49E1-C82C-9920-74B7DD31F188}"/>
               </a:ext>
             </a:extLst>
           </p:cNvPr>
@@ -2631,7 +2631,7 @@
           <a:bodyPr/>
           <a:lstStyle/>
           <a:p>
-            <a:fld id="{645D0087-1160-4B24-BE86-FBB568D75C7A}" type="slidenum">
+            <a:fld id="{C82F3021-0F90-4978-9EEE-C3024DCBA810}" type="slidenum">
               <a:rPr lang="en-US" smtClean="0"/>
               <a:t>‹#›</a:t>
             </a:fld>
@@ -2642,7 +2642,7 @@
     </p:spTree>
     <p:extLst>
       <p:ext uri="{BB962C8B-B14F-4D97-AF65-F5344CB8AC3E}">
-        <p14:creationId xmlns:p14="http://schemas.microsoft.com/office/powerpoint/2010/main" val="322404575"/>
+        <p14:creationId xmlns:p14="http://schemas.microsoft.com/office/powerpoint/2010/main" val="1719571868"/>
       </p:ext>
     </p:extLst>
   </p:cSld>
@@ -2674,7 +2674,7 @@
           <p:cNvPr id="2" name="Vertical Title 1">
             <a:extLst>
               <a:ext uri="{FF2B5EF4-FFF2-40B4-BE49-F238E27FC236}">
-                <a16:creationId xmlns:a16="http://schemas.microsoft.com/office/drawing/2014/main" id="{938F122A-724A-53EC-2586-BDD83E0E06DD}"/>
+                <a16:creationId xmlns:a16="http://schemas.microsoft.com/office/drawing/2014/main" id="{3C0474AA-2AC7-C3C8-2E4D-D2B16E069C40}"/>
               </a:ext>
             </a:extLst>
           </p:cNvPr>
@@ -2707,7 +2707,7 @@
           <p:cNvPr id="3" name="Vertical Text Placeholder 2">
             <a:extLst>
               <a:ext uri="{FF2B5EF4-FFF2-40B4-BE49-F238E27FC236}">
-                <a16:creationId xmlns:a16="http://schemas.microsoft.com/office/drawing/2014/main" id="{A9BB5D05-DC4D-A8F7-EFCE-187A2BFC2072}"/>
+                <a16:creationId xmlns:a16="http://schemas.microsoft.com/office/drawing/2014/main" id="{56BE78EF-DA1F-E30D-8CD0-89F3CC1E7E31}"/>
               </a:ext>
             </a:extLst>
           </p:cNvPr>
@@ -2769,7 +2769,7 @@
           <p:cNvPr id="4" name="Date Placeholder 3">
             <a:extLst>
               <a:ext uri="{FF2B5EF4-FFF2-40B4-BE49-F238E27FC236}">
-                <a16:creationId xmlns:a16="http://schemas.microsoft.com/office/drawing/2014/main" id="{A517FCF2-2857-0335-F576-4C46613D9083}"/>
+                <a16:creationId xmlns:a16="http://schemas.microsoft.com/office/drawing/2014/main" id="{3EDF947F-007C-01ED-DA0B-796ADC3739DF}"/>
               </a:ext>
             </a:extLst>
           </p:cNvPr>
@@ -2785,7 +2785,7 @@
           <a:bodyPr/>
           <a:lstStyle/>
           <a:p>
-            <a:fld id="{CC7F535A-4247-4CDB-B883-63B688F24BAB}" type="datetimeFigureOut">
+            <a:fld id="{C2ECBD91-BFAB-4C42-B9B2-6A9A807B9942}" type="datetimeFigureOut">
               <a:rPr lang="en-US" smtClean="0"/>
               <a:t>10/5/2026</a:t>
             </a:fld>
@@ -2798,7 +2798,7 @@
           <p:cNvPr id="5" name="Footer Placeholder 4">
             <a:extLst>
               <a:ext uri="{FF2B5EF4-FFF2-40B4-BE49-F238E27FC236}">
-                <a16:creationId xmlns:a16="http://schemas.microsoft.com/office/drawing/2014/main" id="{50AE4A25-544E-FE9E-9C3E-B3AC547E0188}"/>
+                <a16:creationId xmlns:a16="http://schemas.microsoft.com/office/drawing/2014/main" id="{6E05B171-FABF-410D-97B2-7D9AAE8CF6C0}"/>
               </a:ext>
             </a:extLst>
           </p:cNvPr>
@@ -2823,7 +2823,7 @@
           <p:cNvPr id="6" name="Slide Number Placeholder 5">
             <a:extLst>
               <a:ext uri="{FF2B5EF4-FFF2-40B4-BE49-F238E27FC236}">
-                <a16:creationId xmlns:a16="http://schemas.microsoft.com/office/drawing/2014/main" id="{1B901593-BC0C-2004-EDF0-61434A262F3E}"/>
+                <a16:creationId xmlns:a16="http://schemas.microsoft.com/office/drawing/2014/main" id="{61C0E0AD-193B-1453-8B87-82C70D2AA735}"/>
               </a:ext>
             </a:extLst>
           </p:cNvPr>
@@ -2839,7 +2839,7 @@
           <a:bodyPr/>
           <a:lstStyle/>
           <a:p>
-            <a:fld id="{645D0087-1160-4B24-BE86-FBB568D75C7A}" type="slidenum">
+            <a:fld id="{C82F3021-0F90-4978-9EEE-C3024DCBA810}" type="slidenum">
               <a:rPr lang="en-US" smtClean="0"/>
               <a:t>‹#›</a:t>
             </a:fld>
@@ -2850,7 +2850,7 @@
     </p:spTree>
     <p:extLst>
       <p:ext uri="{BB962C8B-B14F-4D97-AF65-F5344CB8AC3E}">
-        <p14:creationId xmlns:p14="http://schemas.microsoft.com/office/powerpoint/2010/main" val="2328409301"/>
+        <p14:creationId xmlns:p14="http://schemas.microsoft.com/office/powerpoint/2010/main" val="254918723"/>
       </p:ext>
     </p:extLst>
   </p:cSld>
@@ -2882,7 +2882,7 @@
           <p:cNvPr id="2" name="Title 1">
             <a:extLst>
               <a:ext uri="{FF2B5EF4-FFF2-40B4-BE49-F238E27FC236}">
-                <a16:creationId xmlns:a16="http://schemas.microsoft.com/office/drawing/2014/main" id="{B85A010D-8B78-3393-FE44-DBAB5CA7857E}"/>
+                <a16:creationId xmlns:a16="http://schemas.microsoft.com/office/drawing/2014/main" id="{2D47E456-F6EF-0FD9-2CE8-684129119077}"/>
               </a:ext>
             </a:extLst>
           </p:cNvPr>
@@ -2910,7 +2910,7 @@
           <p:cNvPr id="3" name="Content Placeholder 2">
             <a:extLst>
               <a:ext uri="{FF2B5EF4-FFF2-40B4-BE49-F238E27FC236}">
-                <a16:creationId xmlns:a16="http://schemas.microsoft.com/office/drawing/2014/main" id="{D8EF31FC-5C55-7FC8-CA99-7DD59B94D61E}"/>
+                <a16:creationId xmlns:a16="http://schemas.microsoft.com/office/drawing/2014/main" id="{D7529962-C4DA-AD47-9398-F91E19A9A994}"/>
               </a:ext>
             </a:extLst>
           </p:cNvPr>
@@ -2967,7 +2967,7 @@
           <p:cNvPr id="4" name="Date Placeholder 3">
             <a:extLst>
               <a:ext uri="{FF2B5EF4-FFF2-40B4-BE49-F238E27FC236}">
-                <a16:creationId xmlns:a16="http://schemas.microsoft.com/office/drawing/2014/main" id="{05DEF8B6-D591-CB53-BA98-E26E4D12B0C1}"/>
+                <a16:creationId xmlns:a16="http://schemas.microsoft.com/office/drawing/2014/main" id="{16BD6481-3785-63AE-1F5F-87047F6F97B3}"/>
               </a:ext>
             </a:extLst>
           </p:cNvPr>
@@ -2983,7 +2983,7 @@
           <a:bodyPr/>
           <a:lstStyle/>
           <a:p>
-            <a:fld id="{CC7F535A-4247-4CDB-B883-63B688F24BAB}" type="datetimeFigureOut">
+            <a:fld id="{C2ECBD91-BFAB-4C42-B9B2-6A9A807B9942}" type="datetimeFigureOut">
               <a:rPr lang="en-US" smtClean="0"/>
               <a:t>10/5/2026</a:t>
             </a:fld>
@@ -2996,7 +2996,7 @@
           <p:cNvPr id="5" name="Footer Placeholder 4">
             <a:extLst>
               <a:ext uri="{FF2B5EF4-FFF2-40B4-BE49-F238E27FC236}">
-                <a16:creationId xmlns:a16="http://schemas.microsoft.com/office/drawing/2014/main" id="{9552E8D3-3044-3F71-36AC-D97D9ADDF1E6}"/>
+                <a16:creationId xmlns:a16="http://schemas.microsoft.com/office/drawing/2014/main" id="{AA93AF7B-D7A8-458C-1796-7297426F308A}"/>
               </a:ext>
             </a:extLst>
           </p:cNvPr>
@@ -3021,7 +3021,7 @@
           <p:cNvPr id="6" name="Slide Number Placeholder 5">
             <a:extLst>
               <a:ext uri="{FF2B5EF4-FFF2-40B4-BE49-F238E27FC236}">
-                <a16:creationId xmlns:a16="http://schemas.microsoft.com/office/drawing/2014/main" id="{0B011950-DF66-7391-7DD3-29A15D2F55D8}"/>
+                <a16:creationId xmlns:a16="http://schemas.microsoft.com/office/drawing/2014/main" id="{7189C246-FF55-C55F-AF43-F69A14985218}"/>
               </a:ext>
             </a:extLst>
           </p:cNvPr>
@@ -3037,7 +3037,7 @@
           <a:bodyPr/>
           <a:lstStyle/>
           <a:p>
-            <a:fld id="{645D0087-1160-4B24-BE86-FBB568D75C7A}" type="slidenum">
+            <a:fld id="{C82F3021-0F90-4978-9EEE-C3024DCBA810}" type="slidenum">
               <a:rPr lang="en-US" smtClean="0"/>
               <a:t>‹#›</a:t>
             </a:fld>
@@ -3048,7 +3048,7 @@
     </p:spTree>
     <p:extLst>
       <p:ext uri="{BB962C8B-B14F-4D97-AF65-F5344CB8AC3E}">
-        <p14:creationId xmlns:p14="http://schemas.microsoft.com/office/powerpoint/2010/main" val="4060836856"/>
+        <p14:creationId xmlns:p14="http://schemas.microsoft.com/office/powerpoint/2010/main" val="631120779"/>
       </p:ext>
     </p:extLst>
   </p:cSld>
@@ -3080,7 +3080,7 @@
           <p:cNvPr id="2" name="Title 1">
             <a:extLst>
               <a:ext uri="{FF2B5EF4-FFF2-40B4-BE49-F238E27FC236}">
-                <a16:creationId xmlns:a16="http://schemas.microsoft.com/office/drawing/2014/main" id="{B61DB546-9120-AF1A-EA39-D47E6E0C7894}"/>
+                <a16:creationId xmlns:a16="http://schemas.microsoft.com/office/drawing/2014/main" id="{AFCA4010-C64F-5BD0-3E94-F7A3CC715BA9}"/>
               </a:ext>
             </a:extLst>
           </p:cNvPr>
@@ -3117,7 +3117,7 @@
           <p:cNvPr id="3" name="Text Placeholder 2">
             <a:extLst>
               <a:ext uri="{FF2B5EF4-FFF2-40B4-BE49-F238E27FC236}">
-                <a16:creationId xmlns:a16="http://schemas.microsoft.com/office/drawing/2014/main" id="{899F4ECB-05DE-8845-F47C-3EE2D7B66EF9}"/>
+                <a16:creationId xmlns:a16="http://schemas.microsoft.com/office/drawing/2014/main" id="{CA138361-C989-AB25-16F9-C7445557219B}"/>
               </a:ext>
             </a:extLst>
           </p:cNvPr>
@@ -3242,7 +3242,7 @@
           <p:cNvPr id="4" name="Date Placeholder 3">
             <a:extLst>
               <a:ext uri="{FF2B5EF4-FFF2-40B4-BE49-F238E27FC236}">
-                <a16:creationId xmlns:a16="http://schemas.microsoft.com/office/drawing/2014/main" id="{4EAFE9E1-9CB6-DF0A-A08E-D09DE284C27C}"/>
+                <a16:creationId xmlns:a16="http://schemas.microsoft.com/office/drawing/2014/main" id="{E80AB306-5FBD-B9D6-D6BC-6089928F0E12}"/>
               </a:ext>
             </a:extLst>
           </p:cNvPr>
@@ -3258,7 +3258,7 @@
           <a:bodyPr/>
           <a:lstStyle/>
           <a:p>
-            <a:fld id="{CC7F535A-4247-4CDB-B883-63B688F24BAB}" type="datetimeFigureOut">
+            <a:fld id="{C2ECBD91-BFAB-4C42-B9B2-6A9A807B9942}" type="datetimeFigureOut">
               <a:rPr lang="en-US" smtClean="0"/>
               <a:t>10/5/2026</a:t>
             </a:fld>
@@ -3271,7 +3271,7 @@
           <p:cNvPr id="5" name="Footer Placeholder 4">
             <a:extLst>
               <a:ext uri="{FF2B5EF4-FFF2-40B4-BE49-F238E27FC236}">
-                <a16:creationId xmlns:a16="http://schemas.microsoft.com/office/drawing/2014/main" id="{92CCFD09-404D-1F74-1969-F3790CA65506}"/>
+                <a16:creationId xmlns:a16="http://schemas.microsoft.com/office/drawing/2014/main" id="{1D5D5103-97B1-CA2C-8587-34D1820F6196}"/>
               </a:ext>
             </a:extLst>
           </p:cNvPr>
@@ -3296,7 +3296,7 @@
           <p:cNvPr id="6" name="Slide Number Placeholder 5">
             <a:extLst>
               <a:ext uri="{FF2B5EF4-FFF2-40B4-BE49-F238E27FC236}">
-                <a16:creationId xmlns:a16="http://schemas.microsoft.com/office/drawing/2014/main" id="{51C45C6C-D1F6-5747-3CF2-1BB3ABFC2126}"/>
+                <a16:creationId xmlns:a16="http://schemas.microsoft.com/office/drawing/2014/main" id="{6FDB485D-12D7-F4CE-ABE1-BF8F97BC2397}"/>
               </a:ext>
             </a:extLst>
           </p:cNvPr>
@@ -3312,7 +3312,7 @@
           <a:bodyPr/>
           <a:lstStyle/>
           <a:p>
-            <a:fld id="{645D0087-1160-4B24-BE86-FBB568D75C7A}" type="slidenum">
+            <a:fld id="{C82F3021-0F90-4978-9EEE-C3024DCBA810}" type="slidenum">
               <a:rPr lang="en-US" smtClean="0"/>
               <a:t>‹#›</a:t>
             </a:fld>
@@ -3323,7 +3323,7 @@
     </p:spTree>
     <p:extLst>
       <p:ext uri="{BB962C8B-B14F-4D97-AF65-F5344CB8AC3E}">
-        <p14:creationId xmlns:p14="http://schemas.microsoft.com/office/powerpoint/2010/main" val="3059666997"/>
+        <p14:creationId xmlns:p14="http://schemas.microsoft.com/office/powerpoint/2010/main" val="2748765670"/>
       </p:ext>
     </p:extLst>
   </p:cSld>
@@ -3355,7 +3355,7 @@
           <p:cNvPr id="2" name="Title 1">
             <a:extLst>
               <a:ext uri="{FF2B5EF4-FFF2-40B4-BE49-F238E27FC236}">
-                <a16:creationId xmlns:a16="http://schemas.microsoft.com/office/drawing/2014/main" id="{BDF8C6A8-758E-D396-56E6-4B1576CDB628}"/>
+                <a16:creationId xmlns:a16="http://schemas.microsoft.com/office/drawing/2014/main" id="{CD07E993-AA0F-601E-7B0A-2E6B8CDB2211}"/>
               </a:ext>
             </a:extLst>
           </p:cNvPr>
@@ -3383,7 +3383,7 @@
           <p:cNvPr id="3" name="Content Placeholder 2">
             <a:extLst>
               <a:ext uri="{FF2B5EF4-FFF2-40B4-BE49-F238E27FC236}">
-                <a16:creationId xmlns:a16="http://schemas.microsoft.com/office/drawing/2014/main" id="{C660B9A4-FA82-AF68-9E23-27ED4E1E375E}"/>
+                <a16:creationId xmlns:a16="http://schemas.microsoft.com/office/drawing/2014/main" id="{89C0FAE3-C1A5-D690-17D5-120A46E6FCB2}"/>
               </a:ext>
             </a:extLst>
           </p:cNvPr>
@@ -3445,7 +3445,7 @@
           <p:cNvPr id="4" name="Content Placeholder 3">
             <a:extLst>
               <a:ext uri="{FF2B5EF4-FFF2-40B4-BE49-F238E27FC236}">
-                <a16:creationId xmlns:a16="http://schemas.microsoft.com/office/drawing/2014/main" id="{822B0A54-13F5-B0D7-7989-53AD2E0664A2}"/>
+                <a16:creationId xmlns:a16="http://schemas.microsoft.com/office/drawing/2014/main" id="{B8BA5457-2C61-B82F-2AFF-7A3DD7B9DB30}"/>
               </a:ext>
             </a:extLst>
           </p:cNvPr>
@@ -3507,7 +3507,7 @@
           <p:cNvPr id="5" name="Date Placeholder 4">
             <a:extLst>
               <a:ext uri="{FF2B5EF4-FFF2-40B4-BE49-F238E27FC236}">
-                <a16:creationId xmlns:a16="http://schemas.microsoft.com/office/drawing/2014/main" id="{68D4E2E7-F11E-54F0-0F27-2601C6FB70F6}"/>
+                <a16:creationId xmlns:a16="http://schemas.microsoft.com/office/drawing/2014/main" id="{6D1568B9-EC7C-3D18-0A62-1E10C4132E96}"/>
               </a:ext>
             </a:extLst>
           </p:cNvPr>
@@ -3523,7 +3523,7 @@
           <a:bodyPr/>
           <a:lstStyle/>
           <a:p>
-            <a:fld id="{CC7F535A-4247-4CDB-B883-63B688F24BAB}" type="datetimeFigureOut">
+            <a:fld id="{C2ECBD91-BFAB-4C42-B9B2-6A9A807B9942}" type="datetimeFigureOut">
               <a:rPr lang="en-US" smtClean="0"/>
               <a:t>10/5/2026</a:t>
             </a:fld>
@@ -3536,7 +3536,7 @@
           <p:cNvPr id="6" name="Footer Placeholder 5">
             <a:extLst>
               <a:ext uri="{FF2B5EF4-FFF2-40B4-BE49-F238E27FC236}">
-                <a16:creationId xmlns:a16="http://schemas.microsoft.com/office/drawing/2014/main" id="{38ABB1B9-12F1-F196-CDAE-1AE894228094}"/>
+                <a16:creationId xmlns:a16="http://schemas.microsoft.com/office/drawing/2014/main" id="{2ACF6EA3-4FAC-9983-E4B5-127D96567533}"/>
               </a:ext>
             </a:extLst>
           </p:cNvPr>
@@ -3561,7 +3561,7 @@
           <p:cNvPr id="7" name="Slide Number Placeholder 6">
             <a:extLst>
               <a:ext uri="{FF2B5EF4-FFF2-40B4-BE49-F238E27FC236}">
-                <a16:creationId xmlns:a16="http://schemas.microsoft.com/office/drawing/2014/main" id="{562186C1-BC7B-8842-C832-1A19D3956A02}"/>
+                <a16:creationId xmlns:a16="http://schemas.microsoft.com/office/drawing/2014/main" id="{8C1B6F90-59E2-72CA-04D0-BAA38FFF5B0D}"/>
               </a:ext>
             </a:extLst>
           </p:cNvPr>
@@ -3577,7 +3577,7 @@
           <a:bodyPr/>
           <a:lstStyle/>
           <a:p>
-            <a:fld id="{645D0087-1160-4B24-BE86-FBB568D75C7A}" type="slidenum">
+            <a:fld id="{C82F3021-0F90-4978-9EEE-C3024DCBA810}" type="slidenum">
               <a:rPr lang="en-US" smtClean="0"/>
               <a:t>‹#›</a:t>
             </a:fld>
@@ -3588,7 +3588,7 @@
     </p:spTree>
     <p:extLst>
       <p:ext uri="{BB962C8B-B14F-4D97-AF65-F5344CB8AC3E}">
-        <p14:creationId xmlns:p14="http://schemas.microsoft.com/office/powerpoint/2010/main" val="2472453548"/>
+        <p14:creationId xmlns:p14="http://schemas.microsoft.com/office/powerpoint/2010/main" val="3800933341"/>
       </p:ext>
     </p:extLst>
   </p:cSld>
@@ -3620,7 +3620,7 @@
           <p:cNvPr id="2" name="Title 1">
             <a:extLst>
               <a:ext uri="{FF2B5EF4-FFF2-40B4-BE49-F238E27FC236}">
-                <a16:creationId xmlns:a16="http://schemas.microsoft.com/office/drawing/2014/main" id="{AE88F6FC-8FCC-01E8-7CCF-DF53E01795DF}"/>
+                <a16:creationId xmlns:a16="http://schemas.microsoft.com/office/drawing/2014/main" id="{CDA9D9B0-8186-E6F2-76C2-423CCEAB7AEE}"/>
               </a:ext>
             </a:extLst>
           </p:cNvPr>
@@ -3653,7 +3653,7 @@
           <p:cNvPr id="3" name="Text Placeholder 2">
             <a:extLst>
               <a:ext uri="{FF2B5EF4-FFF2-40B4-BE49-F238E27FC236}">
-                <a16:creationId xmlns:a16="http://schemas.microsoft.com/office/drawing/2014/main" id="{66C2E672-B3B1-B8B1-EE65-5132EEBB3B42}"/>
+                <a16:creationId xmlns:a16="http://schemas.microsoft.com/office/drawing/2014/main" id="{34834314-8C19-7C60-08B9-7E5FA009CCE6}"/>
               </a:ext>
             </a:extLst>
           </p:cNvPr>
@@ -3724,7 +3724,7 @@
           <p:cNvPr id="4" name="Content Placeholder 3">
             <a:extLst>
               <a:ext uri="{FF2B5EF4-FFF2-40B4-BE49-F238E27FC236}">
-                <a16:creationId xmlns:a16="http://schemas.microsoft.com/office/drawing/2014/main" id="{2D7DA56E-4667-0DD3-FDB9-767735E827C6}"/>
+                <a16:creationId xmlns:a16="http://schemas.microsoft.com/office/drawing/2014/main" id="{5BF48DC2-3214-D0D9-6D94-E5F5DDB22808}"/>
               </a:ext>
             </a:extLst>
           </p:cNvPr>
@@ -3786,7 +3786,7 @@
           <p:cNvPr id="5" name="Text Placeholder 4">
             <a:extLst>
               <a:ext uri="{FF2B5EF4-FFF2-40B4-BE49-F238E27FC236}">
-                <a16:creationId xmlns:a16="http://schemas.microsoft.com/office/drawing/2014/main" id="{8FCA2343-D1A1-7BCA-8DBA-6959E299B4BB}"/>
+                <a16:creationId xmlns:a16="http://schemas.microsoft.com/office/drawing/2014/main" id="{7998ACD6-CE37-D445-E56B-B97042A10A97}"/>
               </a:ext>
             </a:extLst>
           </p:cNvPr>
@@ -3857,7 +3857,7 @@
           <p:cNvPr id="6" name="Content Placeholder 5">
             <a:extLst>
               <a:ext uri="{FF2B5EF4-FFF2-40B4-BE49-F238E27FC236}">
-                <a16:creationId xmlns:a16="http://schemas.microsoft.com/office/drawing/2014/main" id="{82BC48E4-F72A-32EC-7CC8-2ABF11897D39}"/>
+                <a16:creationId xmlns:a16="http://schemas.microsoft.com/office/drawing/2014/main" id="{BC46371C-CEDB-CAF1-8BF3-8BC854EF89BF}"/>
               </a:ext>
             </a:extLst>
           </p:cNvPr>
@@ -3919,7 +3919,7 @@
           <p:cNvPr id="7" name="Date Placeholder 6">
             <a:extLst>
               <a:ext uri="{FF2B5EF4-FFF2-40B4-BE49-F238E27FC236}">
-                <a16:creationId xmlns:a16="http://schemas.microsoft.com/office/drawing/2014/main" id="{EC827B96-2C3E-D055-F007-F1012ACA0167}"/>
+                <a16:creationId xmlns:a16="http://schemas.microsoft.com/office/drawing/2014/main" id="{A80BE73F-D99C-C5AC-3736-9C95C4BFA79D}"/>
               </a:ext>
             </a:extLst>
           </p:cNvPr>
@@ -3935,7 +3935,7 @@
           <a:bodyPr/>
           <a:lstStyle/>
           <a:p>
-            <a:fld id="{CC7F535A-4247-4CDB-B883-63B688F24BAB}" type="datetimeFigureOut">
+            <a:fld id="{C2ECBD91-BFAB-4C42-B9B2-6A9A807B9942}" type="datetimeFigureOut">
               <a:rPr lang="en-US" smtClean="0"/>
               <a:t>10/5/2026</a:t>
             </a:fld>
@@ -3948,7 +3948,7 @@
           <p:cNvPr id="8" name="Footer Placeholder 7">
             <a:extLst>
               <a:ext uri="{FF2B5EF4-FFF2-40B4-BE49-F238E27FC236}">
-                <a16:creationId xmlns:a16="http://schemas.microsoft.com/office/drawing/2014/main" id="{DEF110A7-7144-69B9-8F0F-EF1E0DD96839}"/>
+                <a16:creationId xmlns:a16="http://schemas.microsoft.com/office/drawing/2014/main" id="{7D1468B2-269C-EC74-C707-EE2F9C0D3D29}"/>
               </a:ext>
             </a:extLst>
           </p:cNvPr>
@@ -3973,7 +3973,7 @@
           <p:cNvPr id="9" name="Slide Number Placeholder 8">
             <a:extLst>
               <a:ext uri="{FF2B5EF4-FFF2-40B4-BE49-F238E27FC236}">
-                <a16:creationId xmlns:a16="http://schemas.microsoft.com/office/drawing/2014/main" id="{0572C63E-F999-3EE7-C2EF-B86CAA0C6188}"/>
+                <a16:creationId xmlns:a16="http://schemas.microsoft.com/office/drawing/2014/main" id="{37FC1999-455F-8F89-9FB7-5568B8131DEB}"/>
               </a:ext>
             </a:extLst>
           </p:cNvPr>
@@ -3989,7 +3989,7 @@
           <a:bodyPr/>
           <a:lstStyle/>
           <a:p>
-            <a:fld id="{645D0087-1160-4B24-BE86-FBB568D75C7A}" type="slidenum">
+            <a:fld id="{C82F3021-0F90-4978-9EEE-C3024DCBA810}" type="slidenum">
               <a:rPr lang="en-US" smtClean="0"/>
               <a:t>‹#›</a:t>
             </a:fld>
@@ -4000,7 +4000,7 @@
     </p:spTree>
     <p:extLst>
       <p:ext uri="{BB962C8B-B14F-4D97-AF65-F5344CB8AC3E}">
-        <p14:creationId xmlns:p14="http://schemas.microsoft.com/office/powerpoint/2010/main" val="2975742267"/>
+        <p14:creationId xmlns:p14="http://schemas.microsoft.com/office/powerpoint/2010/main" val="146950208"/>
       </p:ext>
     </p:extLst>
   </p:cSld>
@@ -4032,7 +4032,7 @@
           <p:cNvPr id="2" name="Title 1">
             <a:extLst>
               <a:ext uri="{FF2B5EF4-FFF2-40B4-BE49-F238E27FC236}">
-                <a16:creationId xmlns:a16="http://schemas.microsoft.com/office/drawing/2014/main" id="{EEFA811B-196E-9469-8A2A-C171C8A2BBBA}"/>
+                <a16:creationId xmlns:a16="http://schemas.microsoft.com/office/drawing/2014/main" id="{DF1C9393-F008-4848-4FA9-E3FF01CE19DC}"/>
               </a:ext>
             </a:extLst>
           </p:cNvPr>
@@ -4060,7 +4060,7 @@
           <p:cNvPr id="3" name="Date Placeholder 2">
             <a:extLst>
               <a:ext uri="{FF2B5EF4-FFF2-40B4-BE49-F238E27FC236}">
-                <a16:creationId xmlns:a16="http://schemas.microsoft.com/office/drawing/2014/main" id="{19793E76-A845-AF3A-05DB-E73CC994F3B4}"/>
+                <a16:creationId xmlns:a16="http://schemas.microsoft.com/office/drawing/2014/main" id="{2E70B87B-FF05-8620-41EC-8091AB886C3D}"/>
               </a:ext>
             </a:extLst>
           </p:cNvPr>
@@ -4076,7 +4076,7 @@
           <a:bodyPr/>
           <a:lstStyle/>
           <a:p>
-            <a:fld id="{CC7F535A-4247-4CDB-B883-63B688F24BAB}" type="datetimeFigureOut">
+            <a:fld id="{C2ECBD91-BFAB-4C42-B9B2-6A9A807B9942}" type="datetimeFigureOut">
               <a:rPr lang="en-US" smtClean="0"/>
               <a:t>10/5/2026</a:t>
             </a:fld>
@@ -4089,7 +4089,7 @@
           <p:cNvPr id="4" name="Footer Placeholder 3">
             <a:extLst>
               <a:ext uri="{FF2B5EF4-FFF2-40B4-BE49-F238E27FC236}">
-                <a16:creationId xmlns:a16="http://schemas.microsoft.com/office/drawing/2014/main" id="{1B55C0DF-7ED5-2613-B265-E9C983BAA9A8}"/>
+                <a16:creationId xmlns:a16="http://schemas.microsoft.com/office/drawing/2014/main" id="{7BE21B1C-5D86-F961-16C0-F47FAA6C5A75}"/>
               </a:ext>
             </a:extLst>
           </p:cNvPr>
@@ -4114,7 +4114,7 @@
           <p:cNvPr id="5" name="Slide Number Placeholder 4">
             <a:extLst>
               <a:ext uri="{FF2B5EF4-FFF2-40B4-BE49-F238E27FC236}">
-                <a16:creationId xmlns:a16="http://schemas.microsoft.com/office/drawing/2014/main" id="{4E1ABE55-5A03-0B99-3A56-B2F3C3080746}"/>
+                <a16:creationId xmlns:a16="http://schemas.microsoft.com/office/drawing/2014/main" id="{329D5A0F-8BCF-A5A0-6093-9D0F71CEC77A}"/>
               </a:ext>
             </a:extLst>
           </p:cNvPr>
@@ -4130,7 +4130,7 @@
           <a:bodyPr/>
           <a:lstStyle/>
           <a:p>
-            <a:fld id="{645D0087-1160-4B24-BE86-FBB568D75C7A}" type="slidenum">
+            <a:fld id="{C82F3021-0F90-4978-9EEE-C3024DCBA810}" type="slidenum">
               <a:rPr lang="en-US" smtClean="0"/>
               <a:t>‹#›</a:t>
             </a:fld>
@@ -4141,7 +4141,7 @@
     </p:spTree>
     <p:extLst>
       <p:ext uri="{BB962C8B-B14F-4D97-AF65-F5344CB8AC3E}">
-        <p14:creationId xmlns:p14="http://schemas.microsoft.com/office/powerpoint/2010/main" val="1032844044"/>
+        <p14:creationId xmlns:p14="http://schemas.microsoft.com/office/powerpoint/2010/main" val="173379673"/>
       </p:ext>
     </p:extLst>
   </p:cSld>
@@ -4173,7 +4173,7 @@
           <p:cNvPr id="2" name="Date Placeholder 1">
             <a:extLst>
               <a:ext uri="{FF2B5EF4-FFF2-40B4-BE49-F238E27FC236}">
-                <a16:creationId xmlns:a16="http://schemas.microsoft.com/office/drawing/2014/main" id="{6814483F-7274-7E2F-E270-CF9256BA22ED}"/>
+                <a16:creationId xmlns:a16="http://schemas.microsoft.com/office/drawing/2014/main" id="{64717276-5C64-2D95-2BD3-48BA0BFF6FD3}"/>
               </a:ext>
             </a:extLst>
           </p:cNvPr>
@@ -4189,7 +4189,7 @@
           <a:bodyPr/>
           <a:lstStyle/>
           <a:p>
-            <a:fld id="{CC7F535A-4247-4CDB-B883-63B688F24BAB}" type="datetimeFigureOut">
+            <a:fld id="{C2ECBD91-BFAB-4C42-B9B2-6A9A807B9942}" type="datetimeFigureOut">
               <a:rPr lang="en-US" smtClean="0"/>
               <a:t>10/5/2026</a:t>
             </a:fld>
@@ -4202,7 +4202,7 @@
           <p:cNvPr id="3" name="Footer Placeholder 2">
             <a:extLst>
               <a:ext uri="{FF2B5EF4-FFF2-40B4-BE49-F238E27FC236}">
-                <a16:creationId xmlns:a16="http://schemas.microsoft.com/office/drawing/2014/main" id="{3B43A9D0-2CB8-A90A-4237-02F810098686}"/>
+                <a16:creationId xmlns:a16="http://schemas.microsoft.com/office/drawing/2014/main" id="{5AB16CFC-CE0B-A494-0099-214E628C8D6A}"/>
               </a:ext>
             </a:extLst>
           </p:cNvPr>
@@ -4227,7 +4227,7 @@
           <p:cNvPr id="4" name="Slide Number Placeholder 3">
             <a:extLst>
               <a:ext uri="{FF2B5EF4-FFF2-40B4-BE49-F238E27FC236}">
-                <a16:creationId xmlns:a16="http://schemas.microsoft.com/office/drawing/2014/main" id="{BAF227AA-80DE-EBAC-F039-8020021E6DA0}"/>
+                <a16:creationId xmlns:a16="http://schemas.microsoft.com/office/drawing/2014/main" id="{FA6A1B47-86BA-8FB1-59AE-A20D24594CEC}"/>
               </a:ext>
             </a:extLst>
           </p:cNvPr>
@@ -4243,7 +4243,7 @@
           <a:bodyPr/>
           <a:lstStyle/>
           <a:p>
-            <a:fld id="{645D0087-1160-4B24-BE86-FBB568D75C7A}" type="slidenum">
+            <a:fld id="{C82F3021-0F90-4978-9EEE-C3024DCBA810}" type="slidenum">
               <a:rPr lang="en-US" smtClean="0"/>
               <a:t>‹#›</a:t>
             </a:fld>
@@ -4254,7 +4254,7 @@
     </p:spTree>
     <p:extLst>
       <p:ext uri="{BB962C8B-B14F-4D97-AF65-F5344CB8AC3E}">
-        <p14:creationId xmlns:p14="http://schemas.microsoft.com/office/powerpoint/2010/main" val="3876584242"/>
+        <p14:creationId xmlns:p14="http://schemas.microsoft.com/office/powerpoint/2010/main" val="2740258080"/>
       </p:ext>
     </p:extLst>
   </p:cSld>
@@ -4286,7 +4286,7 @@
           <p:cNvPr id="2" name="Title 1">
             <a:extLst>
               <a:ext uri="{FF2B5EF4-FFF2-40B4-BE49-F238E27FC236}">
-                <a16:creationId xmlns:a16="http://schemas.microsoft.com/office/drawing/2014/main" id="{DEE53F43-7397-82D8-525B-219252F4BB8F}"/>
+                <a16:creationId xmlns:a16="http://schemas.microsoft.com/office/drawing/2014/main" id="{48D3F350-6F84-F5DC-0273-6062F2D159C8}"/>
               </a:ext>
             </a:extLst>
           </p:cNvPr>
@@ -4323,7 +4323,7 @@
           <p:cNvPr id="3" name="Content Placeholder 2">
             <a:extLst>
               <a:ext uri="{FF2B5EF4-FFF2-40B4-BE49-F238E27FC236}">
-                <a16:creationId xmlns:a16="http://schemas.microsoft.com/office/drawing/2014/main" id="{46F32F50-B345-80EA-F32E-2C3CF74C89D2}"/>
+                <a16:creationId xmlns:a16="http://schemas.microsoft.com/office/drawing/2014/main" id="{83C51737-ED5A-3DEB-CDC1-2D45AE7F4BA0}"/>
               </a:ext>
             </a:extLst>
           </p:cNvPr>
@@ -4413,7 +4413,7 @@
           <p:cNvPr id="4" name="Text Placeholder 3">
             <a:extLst>
               <a:ext uri="{FF2B5EF4-FFF2-40B4-BE49-F238E27FC236}">
-                <a16:creationId xmlns:a16="http://schemas.microsoft.com/office/drawing/2014/main" id="{015F8AC0-FC7B-1EF2-51A9-56A55E2521EE}"/>
+                <a16:creationId xmlns:a16="http://schemas.microsoft.com/office/drawing/2014/main" id="{B8314B10-4802-3B95-1CA6-E3A07B9BC9C1}"/>
               </a:ext>
             </a:extLst>
           </p:cNvPr>
@@ -4484,7 +4484,7 @@
           <p:cNvPr id="5" name="Date Placeholder 4">
             <a:extLst>
               <a:ext uri="{FF2B5EF4-FFF2-40B4-BE49-F238E27FC236}">
-                <a16:creationId xmlns:a16="http://schemas.microsoft.com/office/drawing/2014/main" id="{77659BF7-16A1-03C9-40A7-DF1759A85798}"/>
+                <a16:creationId xmlns:a16="http://schemas.microsoft.com/office/drawing/2014/main" id="{68DB0876-A897-8FA4-0288-BFC54876431E}"/>
               </a:ext>
             </a:extLst>
           </p:cNvPr>
@@ -4500,7 +4500,7 @@
           <a:bodyPr/>
           <a:lstStyle/>
           <a:p>
-            <a:fld id="{CC7F535A-4247-4CDB-B883-63B688F24BAB}" type="datetimeFigureOut">
+            <a:fld id="{C2ECBD91-BFAB-4C42-B9B2-6A9A807B9942}" type="datetimeFigureOut">
               <a:rPr lang="en-US" smtClean="0"/>
               <a:t>10/5/2026</a:t>
             </a:fld>
@@ -4513,7 +4513,7 @@
           <p:cNvPr id="6" name="Footer Placeholder 5">
             <a:extLst>
               <a:ext uri="{FF2B5EF4-FFF2-40B4-BE49-F238E27FC236}">
-                <a16:creationId xmlns:a16="http://schemas.microsoft.com/office/drawing/2014/main" id="{CDA00D24-F507-A587-73FC-0EDD3A6E4929}"/>
+                <a16:creationId xmlns:a16="http://schemas.microsoft.com/office/drawing/2014/main" id="{17E1B8E8-B5D8-E82A-1362-DE70D9BF5304}"/>
               </a:ext>
             </a:extLst>
           </p:cNvPr>
@@ -4538,7 +4538,7 @@
           <p:cNvPr id="7" name="Slide Number Placeholder 6">
             <a:extLst>
               <a:ext uri="{FF2B5EF4-FFF2-40B4-BE49-F238E27FC236}">
-                <a16:creationId xmlns:a16="http://schemas.microsoft.com/office/drawing/2014/main" id="{AD01F58C-29FB-FD60-7FB7-BA59BF75C0EE}"/>
+                <a16:creationId xmlns:a16="http://schemas.microsoft.com/office/drawing/2014/main" id="{7E015EC9-35E8-C824-720A-00D7D0151E88}"/>
               </a:ext>
             </a:extLst>
           </p:cNvPr>
@@ -4554,7 +4554,7 @@
           <a:bodyPr/>
           <a:lstStyle/>
           <a:p>
-            <a:fld id="{645D0087-1160-4B24-BE86-FBB568D75C7A}" type="slidenum">
+            <a:fld id="{C82F3021-0F90-4978-9EEE-C3024DCBA810}" type="slidenum">
               <a:rPr lang="en-US" smtClean="0"/>
               <a:t>‹#›</a:t>
             </a:fld>
@@ -4565,7 +4565,7 @@
     </p:spTree>
     <p:extLst>
       <p:ext uri="{BB962C8B-B14F-4D97-AF65-F5344CB8AC3E}">
-        <p14:creationId xmlns:p14="http://schemas.microsoft.com/office/powerpoint/2010/main" val="3539954793"/>
+        <p14:creationId xmlns:p14="http://schemas.microsoft.com/office/powerpoint/2010/main" val="3628989753"/>
       </p:ext>
     </p:extLst>
   </p:cSld>
@@ -4597,7 +4597,7 @@
           <p:cNvPr id="2" name="Title 1">
             <a:extLst>
               <a:ext uri="{FF2B5EF4-FFF2-40B4-BE49-F238E27FC236}">
-                <a16:creationId xmlns:a16="http://schemas.microsoft.com/office/drawing/2014/main" id="{58683D6C-8EFD-7D3D-DEF7-7C8A8A0E3792}"/>
+                <a16:creationId xmlns:a16="http://schemas.microsoft.com/office/drawing/2014/main" id="{978B5048-A8F4-AF43-6A07-CDBE1CA20B36}"/>
               </a:ext>
             </a:extLst>
           </p:cNvPr>
@@ -4634,7 +4634,7 @@
           <p:cNvPr id="3" name="Picture Placeholder 2">
             <a:extLst>
               <a:ext uri="{FF2B5EF4-FFF2-40B4-BE49-F238E27FC236}">
-                <a16:creationId xmlns:a16="http://schemas.microsoft.com/office/drawing/2014/main" id="{22B74C38-DED8-DB05-579F-98AC0AE5567F}"/>
+                <a16:creationId xmlns:a16="http://schemas.microsoft.com/office/drawing/2014/main" id="{CC5EF3C9-BC14-5604-26EA-1D42A1A0F39B}"/>
               </a:ext>
             </a:extLst>
           </p:cNvPr>
@@ -4701,7 +4701,7 @@
           <p:cNvPr id="4" name="Text Placeholder 3">
             <a:extLst>
               <a:ext uri="{FF2B5EF4-FFF2-40B4-BE49-F238E27FC236}">
-                <a16:creationId xmlns:a16="http://schemas.microsoft.com/office/drawing/2014/main" id="{65515300-DED5-ECD6-C52F-C146A3BF12E4}"/>
+                <a16:creationId xmlns:a16="http://schemas.microsoft.com/office/drawing/2014/main" id="{762E2B05-4AD4-FE00-8C0D-9957161FA890}"/>
               </a:ext>
             </a:extLst>
           </p:cNvPr>
@@ -4772,7 +4772,7 @@
           <p:cNvPr id="5" name="Date Placeholder 4">
             <a:extLst>
               <a:ext uri="{FF2B5EF4-FFF2-40B4-BE49-F238E27FC236}">
-                <a16:creationId xmlns:a16="http://schemas.microsoft.com/office/drawing/2014/main" id="{5DA18266-6E54-C46D-BA44-9BA744C2F2AF}"/>
+                <a16:creationId xmlns:a16="http://schemas.microsoft.com/office/drawing/2014/main" id="{E51AF146-693E-9E68-968A-ABB56DB1B0E0}"/>
               </a:ext>
             </a:extLst>
           </p:cNvPr>
@@ -4788,7 +4788,7 @@
           <a:bodyPr/>
           <a:lstStyle/>
           <a:p>
-            <a:fld id="{CC7F535A-4247-4CDB-B883-63B688F24BAB}" type="datetimeFigureOut">
+            <a:fld id="{C2ECBD91-BFAB-4C42-B9B2-6A9A807B9942}" type="datetimeFigureOut">
               <a:rPr lang="en-US" smtClean="0"/>
               <a:t>10/5/2026</a:t>
             </a:fld>
@@ -4801,7 +4801,7 @@
           <p:cNvPr id="6" name="Footer Placeholder 5">
             <a:extLst>
               <a:ext uri="{FF2B5EF4-FFF2-40B4-BE49-F238E27FC236}">
-                <a16:creationId xmlns:a16="http://schemas.microsoft.com/office/drawing/2014/main" id="{00127769-1253-A7FC-3CCE-9A910D46B2F1}"/>
+                <a16:creationId xmlns:a16="http://schemas.microsoft.com/office/drawing/2014/main" id="{4F6F93E2-E656-9286-A9C8-52046A94A672}"/>
               </a:ext>
             </a:extLst>
           </p:cNvPr>
@@ -4826,7 +4826,7 @@
           <p:cNvPr id="7" name="Slide Number Placeholder 6">
             <a:extLst>
               <a:ext uri="{FF2B5EF4-FFF2-40B4-BE49-F238E27FC236}">
-                <a16:creationId xmlns:a16="http://schemas.microsoft.com/office/drawing/2014/main" id="{9C107E5F-24B7-A2F7-6658-03884594B17E}"/>
+                <a16:creationId xmlns:a16="http://schemas.microsoft.com/office/drawing/2014/main" id="{72B41725-3174-D3CB-C8B9-4B12158B1799}"/>
               </a:ext>
             </a:extLst>
           </p:cNvPr>
@@ -4842,7 +4842,7 @@
           <a:bodyPr/>
           <a:lstStyle/>
           <a:p>
-            <a:fld id="{645D0087-1160-4B24-BE86-FBB568D75C7A}" type="slidenum">
+            <a:fld id="{C82F3021-0F90-4978-9EEE-C3024DCBA810}" type="slidenum">
               <a:rPr lang="en-US" smtClean="0"/>
               <a:t>‹#›</a:t>
             </a:fld>
@@ -4853,7 +4853,7 @@
     </p:spTree>
     <p:extLst>
       <p:ext uri="{BB962C8B-B14F-4D97-AF65-F5344CB8AC3E}">
-        <p14:creationId xmlns:p14="http://schemas.microsoft.com/office/powerpoint/2010/main" val="1260560626"/>
+        <p14:creationId xmlns:p14="http://schemas.microsoft.com/office/powerpoint/2010/main" val="4099409233"/>
       </p:ext>
     </p:extLst>
   </p:cSld>
@@ -4890,7 +4890,7 @@
           <p:cNvPr id="2" name="Title Placeholder 1">
             <a:extLst>
               <a:ext uri="{FF2B5EF4-FFF2-40B4-BE49-F238E27FC236}">
-                <a16:creationId xmlns:a16="http://schemas.microsoft.com/office/drawing/2014/main" id="{7AF7C4FF-2965-DB0E-5953-5608E843771D}"/>
+                <a16:creationId xmlns:a16="http://schemas.microsoft.com/office/drawing/2014/main" id="{64F7660F-A4E3-A8E2-8AB2-050B10A6BF45}"/>
               </a:ext>
             </a:extLst>
           </p:cNvPr>
@@ -4928,7 +4928,7 @@
           <p:cNvPr id="3" name="Text Placeholder 2">
             <a:extLst>
               <a:ext uri="{FF2B5EF4-FFF2-40B4-BE49-F238E27FC236}">
-                <a16:creationId xmlns:a16="http://schemas.microsoft.com/office/drawing/2014/main" id="{C0775B0B-6E7A-6A36-4B5A-B9A87084AFB0}"/>
+                <a16:creationId xmlns:a16="http://schemas.microsoft.com/office/drawing/2014/main" id="{FCEDBCA5-AFAB-5C2C-C6BA-9EB7674C19BF}"/>
               </a:ext>
             </a:extLst>
           </p:cNvPr>
@@ -4995,7 +4995,7 @@
           <p:cNvPr id="4" name="Date Placeholder 3">
             <a:extLst>
               <a:ext uri="{FF2B5EF4-FFF2-40B4-BE49-F238E27FC236}">
-                <a16:creationId xmlns:a16="http://schemas.microsoft.com/office/drawing/2014/main" id="{B2813EED-2AAE-4DCC-40BA-A06BF74114F6}"/>
+                <a16:creationId xmlns:a16="http://schemas.microsoft.com/office/drawing/2014/main" id="{55777C42-A8B8-F831-178F-2942817BF186}"/>
               </a:ext>
             </a:extLst>
           </p:cNvPr>
@@ -5029,7 +5029,7 @@
             </a:lvl1pPr>
           </a:lstStyle>
           <a:p>
-            <a:fld id="{CC7F535A-4247-4CDB-B883-63B688F24BAB}" type="datetimeFigureOut">
+            <a:fld id="{C2ECBD91-BFAB-4C42-B9B2-6A9A807B9942}" type="datetimeFigureOut">
               <a:rPr lang="en-US" smtClean="0"/>
               <a:t>10/5/2026</a:t>
             </a:fld>
@@ -5042,7 +5042,7 @@
           <p:cNvPr id="5" name="Footer Placeholder 4">
             <a:extLst>
               <a:ext uri="{FF2B5EF4-FFF2-40B4-BE49-F238E27FC236}">
-                <a16:creationId xmlns:a16="http://schemas.microsoft.com/office/drawing/2014/main" id="{83C0F634-FA0C-6E67-DA14-4EAD10753DFC}"/>
+                <a16:creationId xmlns:a16="http://schemas.microsoft.com/office/drawing/2014/main" id="{6AF9385B-DB91-E879-3045-3A27C224D17E}"/>
               </a:ext>
             </a:extLst>
           </p:cNvPr>
@@ -5085,7 +5085,7 @@
           <p:cNvPr id="6" name="Slide Number Placeholder 5">
             <a:extLst>
               <a:ext uri="{FF2B5EF4-FFF2-40B4-BE49-F238E27FC236}">
-                <a16:creationId xmlns:a16="http://schemas.microsoft.com/office/drawing/2014/main" id="{1E77F508-FA07-5A8C-5FFB-E4B48CAB1ECB}"/>
+                <a16:creationId xmlns:a16="http://schemas.microsoft.com/office/drawing/2014/main" id="{7210692B-C8A6-233D-5E1A-BF50FDD3FB65}"/>
               </a:ext>
             </a:extLst>
           </p:cNvPr>
@@ -5119,7 +5119,7 @@
             </a:lvl1pPr>
           </a:lstStyle>
           <a:p>
-            <a:fld id="{645D0087-1160-4B24-BE86-FBB568D75C7A}" type="slidenum">
+            <a:fld id="{C82F3021-0F90-4978-9EEE-C3024DCBA810}" type="slidenum">
               <a:rPr lang="en-US" smtClean="0"/>
               <a:t>‹#›</a:t>
             </a:fld>
@@ -5130,7 +5130,7 @@
     </p:spTree>
     <p:extLst>
       <p:ext uri="{BB962C8B-B14F-4D97-AF65-F5344CB8AC3E}">
-        <p14:creationId xmlns:p14="http://schemas.microsoft.com/office/powerpoint/2010/main" val="2429503139"/>
+        <p14:creationId xmlns:p14="http://schemas.microsoft.com/office/powerpoint/2010/main" val="980489423"/>
       </p:ext>
     </p:extLst>
   </p:cSld>
@@ -5461,7 +5461,7 @@
           <p:cNvPr id="2" name="TextBox 1">
             <a:extLst>
               <a:ext uri="{FF2B5EF4-FFF2-40B4-BE49-F238E27FC236}">
-                <a16:creationId xmlns:a16="http://schemas.microsoft.com/office/drawing/2014/main" id="{669EDFDE-DF79-84FC-39DD-A4DEB19CF98B}"/>
+                <a16:creationId xmlns:a16="http://schemas.microsoft.com/office/drawing/2014/main" id="{3891002B-CED3-CF2B-59EA-7FDC9D824824}"/>
               </a:ext>
             </a:extLst>
           </p:cNvPr>
@@ -5506,7 +5506,7 @@
           <p:cNvPr id="3" name="TextBox 2">
             <a:extLst>
               <a:ext uri="{FF2B5EF4-FFF2-40B4-BE49-F238E27FC236}">
-                <a16:creationId xmlns:a16="http://schemas.microsoft.com/office/drawing/2014/main" id="{B81CDB2D-99DD-53E6-8AA1-50B784BFBF6C}"/>
+                <a16:creationId xmlns:a16="http://schemas.microsoft.com/office/drawing/2014/main" id="{74AD1B38-C628-959E-B370-CE9EDD76C5B0}"/>
               </a:ext>
             </a:extLst>
           </p:cNvPr>
@@ -5551,7 +5551,7 @@
           <p:cNvPr id="4" name="TextBox 3">
             <a:extLst>
               <a:ext uri="{FF2B5EF4-FFF2-40B4-BE49-F238E27FC236}">
-                <a16:creationId xmlns:a16="http://schemas.microsoft.com/office/drawing/2014/main" id="{B8863D3A-65D6-8401-575C-F7BA87B6136F}"/>
+                <a16:creationId xmlns:a16="http://schemas.microsoft.com/office/drawing/2014/main" id="{9CD80212-6ADF-134B-9EAE-3B8E61DC10E8}"/>
               </a:ext>
             </a:extLst>
           </p:cNvPr>
@@ -5626,7 +5626,7 @@
     </p:spTree>
     <p:extLst>
       <p:ext uri="{BB962C8B-B14F-4D97-AF65-F5344CB8AC3E}">
-        <p14:creationId xmlns:p14="http://schemas.microsoft.com/office/powerpoint/2010/main" val="3435403948"/>
+        <p14:creationId xmlns:p14="http://schemas.microsoft.com/office/powerpoint/2010/main" val="1323076609"/>
       </p:ext>
     </p:extLst>
   </p:cSld>
@@ -5666,7 +5666,7 @@
           <p:cNvPr id="2" name="TextBox 1">
             <a:extLst>
               <a:ext uri="{FF2B5EF4-FFF2-40B4-BE49-F238E27FC236}">
-                <a16:creationId xmlns:a16="http://schemas.microsoft.com/office/drawing/2014/main" id="{6F57CDFF-CF15-BD99-4BB6-F8DF6A0F814F}"/>
+                <a16:creationId xmlns:a16="http://schemas.microsoft.com/office/drawing/2014/main" id="{D6123BFE-0CC6-3EBC-C88F-74A419659C35}"/>
               </a:ext>
             </a:extLst>
           </p:cNvPr>
@@ -5711,7 +5711,7 @@
           <p:cNvPr id="3" name="TextBox 2">
             <a:extLst>
               <a:ext uri="{FF2B5EF4-FFF2-40B4-BE49-F238E27FC236}">
-                <a16:creationId xmlns:a16="http://schemas.microsoft.com/office/drawing/2014/main" id="{C176D273-365E-9A1F-FE26-37309D919B82}"/>
+                <a16:creationId xmlns:a16="http://schemas.microsoft.com/office/drawing/2014/main" id="{EAE7567B-B36D-DA29-9B35-D8D3D89685C7}"/>
               </a:ext>
             </a:extLst>
           </p:cNvPr>
@@ -5756,7 +5756,7 @@
           <p:cNvPr id="5" name="Picture 4">
             <a:extLst>
               <a:ext uri="{FF2B5EF4-FFF2-40B4-BE49-F238E27FC236}">
-                <a16:creationId xmlns:a16="http://schemas.microsoft.com/office/drawing/2014/main" id="{8462F713-AAC0-EF18-7A87-080A9140BF22}"/>
+                <a16:creationId xmlns:a16="http://schemas.microsoft.com/office/drawing/2014/main" id="{7BC9697B-16E8-B930-0504-4F26157CA466}"/>
               </a:ext>
             </a:extLst>
           </p:cNvPr>
@@ -5792,7 +5792,7 @@
           <p:cNvPr id="6" name="TextBox 5">
             <a:extLst>
               <a:ext uri="{FF2B5EF4-FFF2-40B4-BE49-F238E27FC236}">
-                <a16:creationId xmlns:a16="http://schemas.microsoft.com/office/drawing/2014/main" id="{79684538-C983-FC40-5BF6-44DDDDE8829B}"/>
+                <a16:creationId xmlns:a16="http://schemas.microsoft.com/office/drawing/2014/main" id="{4472341F-7A02-3C85-61CD-471F2E568BA3}"/>
               </a:ext>
             </a:extLst>
           </p:cNvPr>
@@ -5835,7 +5835,7 @@
     </p:spTree>
     <p:extLst>
       <p:ext uri="{BB962C8B-B14F-4D97-AF65-F5344CB8AC3E}">
-        <p14:creationId xmlns:p14="http://schemas.microsoft.com/office/powerpoint/2010/main" val="404286885"/>
+        <p14:creationId xmlns:p14="http://schemas.microsoft.com/office/powerpoint/2010/main" val="48103974"/>
       </p:ext>
     </p:extLst>
   </p:cSld>
@@ -5875,7 +5875,7 @@
           <p:cNvPr id="2" name="TextBox 1">
             <a:extLst>
               <a:ext uri="{FF2B5EF4-FFF2-40B4-BE49-F238E27FC236}">
-                <a16:creationId xmlns:a16="http://schemas.microsoft.com/office/drawing/2014/main" id="{93FE9875-E7A7-1C0F-CEB1-4D823E5A9CF3}"/>
+                <a16:creationId xmlns:a16="http://schemas.microsoft.com/office/drawing/2014/main" id="{3643EB51-3C33-BAFD-B368-5D9951CCA487}"/>
               </a:ext>
             </a:extLst>
           </p:cNvPr>
@@ -5920,7 +5920,7 @@
           <p:cNvPr id="3" name="TextBox 2">
             <a:extLst>
               <a:ext uri="{FF2B5EF4-FFF2-40B4-BE49-F238E27FC236}">
-                <a16:creationId xmlns:a16="http://schemas.microsoft.com/office/drawing/2014/main" id="{15791690-A01E-EAE8-8FE8-0D34E841111C}"/>
+                <a16:creationId xmlns:a16="http://schemas.microsoft.com/office/drawing/2014/main" id="{AFDB1DD2-247C-6025-979A-DD5040CF642F}"/>
               </a:ext>
             </a:extLst>
           </p:cNvPr>
@@ -5965,7 +5965,7 @@
           <p:cNvPr id="4" name="TextBox 3">
             <a:extLst>
               <a:ext uri="{FF2B5EF4-FFF2-40B4-BE49-F238E27FC236}">
-                <a16:creationId xmlns:a16="http://schemas.microsoft.com/office/drawing/2014/main" id="{B158446E-EA16-9505-C3C4-D2E4B58E3CB3}"/>
+                <a16:creationId xmlns:a16="http://schemas.microsoft.com/office/drawing/2014/main" id="{02D06812-F9B5-DDDF-6670-49FF175E5380}"/>
               </a:ext>
             </a:extLst>
           </p:cNvPr>
@@ -6010,7 +6010,7 @@
           <p:cNvPr id="5" name="TextBox 4">
             <a:extLst>
               <a:ext uri="{FF2B5EF4-FFF2-40B4-BE49-F238E27FC236}">
-                <a16:creationId xmlns:a16="http://schemas.microsoft.com/office/drawing/2014/main" id="{C902178A-1484-CDC2-F7CD-4E4F207573A4}"/>
+                <a16:creationId xmlns:a16="http://schemas.microsoft.com/office/drawing/2014/main" id="{7DD8726B-4B30-8C6B-5BA7-F3C7271177C9}"/>
               </a:ext>
             </a:extLst>
           </p:cNvPr>
@@ -6055,7 +6055,7 @@
           <p:cNvPr id="6" name="TextBox 5">
             <a:extLst>
               <a:ext uri="{FF2B5EF4-FFF2-40B4-BE49-F238E27FC236}">
-                <a16:creationId xmlns:a16="http://schemas.microsoft.com/office/drawing/2014/main" id="{31A791EB-C72E-951D-56AA-2EFC7886DD1E}"/>
+                <a16:creationId xmlns:a16="http://schemas.microsoft.com/office/drawing/2014/main" id="{A6321684-9A65-A4BB-92DE-89F399F8740D}"/>
               </a:ext>
             </a:extLst>
           </p:cNvPr>
@@ -6100,7 +6100,7 @@
           <p:cNvPr id="7" name="TextBox 6">
             <a:extLst>
               <a:ext uri="{FF2B5EF4-FFF2-40B4-BE49-F238E27FC236}">
-                <a16:creationId xmlns:a16="http://schemas.microsoft.com/office/drawing/2014/main" id="{AFF8DE0A-95E0-9099-906F-F2C4FDBADC53}"/>
+                <a16:creationId xmlns:a16="http://schemas.microsoft.com/office/drawing/2014/main" id="{24A67EF6-E240-240E-96EF-56CE554CEFE8}"/>
               </a:ext>
             </a:extLst>
           </p:cNvPr>
@@ -6143,7 +6143,7 @@
     </p:spTree>
     <p:extLst>
       <p:ext uri="{BB962C8B-B14F-4D97-AF65-F5344CB8AC3E}">
-        <p14:creationId xmlns:p14="http://schemas.microsoft.com/office/powerpoint/2010/main" val="1528326716"/>
+        <p14:creationId xmlns:p14="http://schemas.microsoft.com/office/powerpoint/2010/main" val="2867239975"/>
       </p:ext>
     </p:extLst>
   </p:cSld>
@@ -6183,7 +6183,7 @@
           <p:cNvPr id="2" name="TextBox 1">
             <a:extLst>
               <a:ext uri="{FF2B5EF4-FFF2-40B4-BE49-F238E27FC236}">
-                <a16:creationId xmlns:a16="http://schemas.microsoft.com/office/drawing/2014/main" id="{29B9F57F-4F7F-D936-4E17-25957E98D45F}"/>
+                <a16:creationId xmlns:a16="http://schemas.microsoft.com/office/drawing/2014/main" id="{2D179B6B-B5D2-119D-7D6A-33406AE4BC89}"/>
               </a:ext>
             </a:extLst>
           </p:cNvPr>
@@ -6228,7 +6228,7 @@
           <p:cNvPr id="3" name="TextBox 2">
             <a:extLst>
               <a:ext uri="{FF2B5EF4-FFF2-40B4-BE49-F238E27FC236}">
-                <a16:creationId xmlns:a16="http://schemas.microsoft.com/office/drawing/2014/main" id="{CE9D22A6-7B3C-D238-7640-5791EBA3BEB0}"/>
+                <a16:creationId xmlns:a16="http://schemas.microsoft.com/office/drawing/2014/main" id="{C7A7FB21-EB14-41D2-CF4E-669B1864E815}"/>
               </a:ext>
             </a:extLst>
           </p:cNvPr>
@@ -6273,7 +6273,7 @@
           <p:cNvPr id="4" name="Table 3">
             <a:extLst>
               <a:ext uri="{FF2B5EF4-FFF2-40B4-BE49-F238E27FC236}">
-                <a16:creationId xmlns:a16="http://schemas.microsoft.com/office/drawing/2014/main" id="{65D76416-0C2E-C1BE-C138-815B39EBEDD2}"/>
+                <a16:creationId xmlns:a16="http://schemas.microsoft.com/office/drawing/2014/main" id="{DD9E5D46-17CE-38E2-0900-E693923C29FD}"/>
               </a:ext>
             </a:extLst>
           </p:cNvPr>
@@ -6283,7 +6283,7 @@
           <p:nvPr>
             <p:extLst>
               <p:ext uri="{D42A27DB-BD31-4B8C-83A1-F6EECF244321}">
-                <p14:modId xmlns:p14="http://schemas.microsoft.com/office/powerpoint/2010/main" val="473824171"/>
+                <p14:modId xmlns:p14="http://schemas.microsoft.com/office/powerpoint/2010/main" val="2902652419"/>
               </p:ext>
             </p:extLst>
           </p:nvPr>
@@ -6302,14 +6302,14 @@
                 <a:gridCol w="5397500">
                   <a:extLst>
                     <a:ext uri="{9D8B030D-6E8A-4147-A177-3AD203B41FA5}">
-                      <a16:colId xmlns:a16="http://schemas.microsoft.com/office/drawing/2014/main" val="2752793812"/>
+                      <a16:colId xmlns:a16="http://schemas.microsoft.com/office/drawing/2014/main" val="942417288"/>
                     </a:ext>
                   </a:extLst>
                 </a:gridCol>
                 <a:gridCol w="5397500">
                   <a:extLst>
                     <a:ext uri="{9D8B030D-6E8A-4147-A177-3AD203B41FA5}">
-                      <a16:colId xmlns:a16="http://schemas.microsoft.com/office/drawing/2014/main" val="2644732755"/>
+                      <a16:colId xmlns:a16="http://schemas.microsoft.com/office/drawing/2014/main" val="2657566344"/>
                     </a:ext>
                   </a:extLst>
                 </a:gridCol>
@@ -6361,7 +6361,7 @@
                 </a:tc>
                 <a:extLst>
                   <a:ext uri="{0D108BD9-81ED-4DB2-BD59-A6C34878D82A}">
-                    <a16:rowId xmlns:a16="http://schemas.microsoft.com/office/drawing/2014/main" val="2264930629"/>
+                    <a16:rowId xmlns:a16="http://schemas.microsoft.com/office/drawing/2014/main" val="4207532210"/>
                   </a:ext>
                 </a:extLst>
               </a:tr>
@@ -6418,7 +6418,7 @@
                 </a:tc>
                 <a:extLst>
                   <a:ext uri="{0D108BD9-81ED-4DB2-BD59-A6C34878D82A}">
-                    <a16:rowId xmlns:a16="http://schemas.microsoft.com/office/drawing/2014/main" val="2502144121"/>
+                    <a16:rowId xmlns:a16="http://schemas.microsoft.com/office/drawing/2014/main" val="2598796305"/>
                   </a:ext>
                 </a:extLst>
               </a:tr>
@@ -6475,7 +6475,7 @@
                 </a:tc>
                 <a:extLst>
                   <a:ext uri="{0D108BD9-81ED-4DB2-BD59-A6C34878D82A}">
-                    <a16:rowId xmlns:a16="http://schemas.microsoft.com/office/drawing/2014/main" val="1431812503"/>
+                    <a16:rowId xmlns:a16="http://schemas.microsoft.com/office/drawing/2014/main" val="521554410"/>
                   </a:ext>
                 </a:extLst>
               </a:tr>
@@ -6526,7 +6526,7 @@
                 </a:tc>
                 <a:extLst>
                   <a:ext uri="{0D108BD9-81ED-4DB2-BD59-A6C34878D82A}">
-                    <a16:rowId xmlns:a16="http://schemas.microsoft.com/office/drawing/2014/main" val="4202214644"/>
+                    <a16:rowId xmlns:a16="http://schemas.microsoft.com/office/drawing/2014/main" val="192806625"/>
                   </a:ext>
                 </a:extLst>
               </a:tr>
@@ -6583,7 +6583,7 @@
                 </a:tc>
                 <a:extLst>
                   <a:ext uri="{0D108BD9-81ED-4DB2-BD59-A6C34878D82A}">
-                    <a16:rowId xmlns:a16="http://schemas.microsoft.com/office/drawing/2014/main" val="3253311293"/>
+                    <a16:rowId xmlns:a16="http://schemas.microsoft.com/office/drawing/2014/main" val="2461150287"/>
                   </a:ext>
                 </a:extLst>
               </a:tr>
@@ -6634,7 +6634,7 @@
                 </a:tc>
                 <a:extLst>
                   <a:ext uri="{0D108BD9-81ED-4DB2-BD59-A6C34878D82A}">
-                    <a16:rowId xmlns:a16="http://schemas.microsoft.com/office/drawing/2014/main" val="187274895"/>
+                    <a16:rowId xmlns:a16="http://schemas.microsoft.com/office/drawing/2014/main" val="3804133906"/>
                   </a:ext>
                 </a:extLst>
               </a:tr>
@@ -6645,7 +6645,7 @@
     </p:spTree>
     <p:extLst>
       <p:ext uri="{BB962C8B-B14F-4D97-AF65-F5344CB8AC3E}">
-        <p14:creationId xmlns:p14="http://schemas.microsoft.com/office/powerpoint/2010/main" val="2022325777"/>
+        <p14:creationId xmlns:p14="http://schemas.microsoft.com/office/powerpoint/2010/main" val="1187672628"/>
       </p:ext>
     </p:extLst>
   </p:cSld>
@@ -6685,7 +6685,7 @@
           <p:cNvPr id="2" name="TextBox 1">
             <a:extLst>
               <a:ext uri="{FF2B5EF4-FFF2-40B4-BE49-F238E27FC236}">
-                <a16:creationId xmlns:a16="http://schemas.microsoft.com/office/drawing/2014/main" id="{7858D6E5-73B5-82C2-EDA1-2E5EE0F997E8}"/>
+                <a16:creationId xmlns:a16="http://schemas.microsoft.com/office/drawing/2014/main" id="{84C3264B-EB09-9851-1ECE-BC005565A439}"/>
               </a:ext>
             </a:extLst>
           </p:cNvPr>
@@ -6730,7 +6730,7 @@
           <p:cNvPr id="3" name="TextBox 2">
             <a:extLst>
               <a:ext uri="{FF2B5EF4-FFF2-40B4-BE49-F238E27FC236}">
-                <a16:creationId xmlns:a16="http://schemas.microsoft.com/office/drawing/2014/main" id="{6032188E-8F55-91D5-FDC0-33BCFFC3267D}"/>
+                <a16:creationId xmlns:a16="http://schemas.microsoft.com/office/drawing/2014/main" id="{939526D7-994C-50FF-132B-19BF932B9577}"/>
               </a:ext>
             </a:extLst>
           </p:cNvPr>
@@ -6775,7 +6775,7 @@
           <p:cNvPr id="4" name="Table 3">
             <a:extLst>
               <a:ext uri="{FF2B5EF4-FFF2-40B4-BE49-F238E27FC236}">
-                <a16:creationId xmlns:a16="http://schemas.microsoft.com/office/drawing/2014/main" id="{9CFAD6F1-40D4-5721-FA53-E25EE1163888}"/>
+                <a16:creationId xmlns:a16="http://schemas.microsoft.com/office/drawing/2014/main" id="{13E2E947-4A20-FC88-C942-5EEA97D8B5DC}"/>
               </a:ext>
             </a:extLst>
           </p:cNvPr>
@@ -6785,7 +6785,7 @@
           <p:nvPr>
             <p:extLst>
               <p:ext uri="{D42A27DB-BD31-4B8C-83A1-F6EECF244321}">
-                <p14:modId xmlns:p14="http://schemas.microsoft.com/office/powerpoint/2010/main" val="3204571978"/>
+                <p14:modId xmlns:p14="http://schemas.microsoft.com/office/powerpoint/2010/main" val="1419866061"/>
               </p:ext>
             </p:extLst>
           </p:nvPr>
@@ -6804,21 +6804,21 @@
                 <a:gridCol w="3598333">
                   <a:extLst>
                     <a:ext uri="{9D8B030D-6E8A-4147-A177-3AD203B41FA5}">
-                      <a16:colId xmlns:a16="http://schemas.microsoft.com/office/drawing/2014/main" val="1698267028"/>
+                      <a16:colId xmlns:a16="http://schemas.microsoft.com/office/drawing/2014/main" val="3133433602"/>
                     </a:ext>
                   </a:extLst>
                 </a:gridCol>
                 <a:gridCol w="3598333">
                   <a:extLst>
                     <a:ext uri="{9D8B030D-6E8A-4147-A177-3AD203B41FA5}">
-                      <a16:colId xmlns:a16="http://schemas.microsoft.com/office/drawing/2014/main" val="1283416471"/>
+                      <a16:colId xmlns:a16="http://schemas.microsoft.com/office/drawing/2014/main" val="3173979198"/>
                     </a:ext>
                   </a:extLst>
                 </a:gridCol>
                 <a:gridCol w="3598333">
                   <a:extLst>
                     <a:ext uri="{9D8B030D-6E8A-4147-A177-3AD203B41FA5}">
-                      <a16:colId xmlns:a16="http://schemas.microsoft.com/office/drawing/2014/main" val="1849162870"/>
+                      <a16:colId xmlns:a16="http://schemas.microsoft.com/office/drawing/2014/main" val="4149978696"/>
                     </a:ext>
                   </a:extLst>
                 </a:gridCol>
@@ -6892,7 +6892,7 @@
                 </a:tc>
                 <a:extLst>
                   <a:ext uri="{0D108BD9-81ED-4DB2-BD59-A6C34878D82A}">
-                    <a16:rowId xmlns:a16="http://schemas.microsoft.com/office/drawing/2014/main" val="4256332736"/>
+                    <a16:rowId xmlns:a16="http://schemas.microsoft.com/office/drawing/2014/main" val="700339096"/>
                   </a:ext>
                 </a:extLst>
               </a:tr>
@@ -6965,7 +6965,7 @@
                 </a:tc>
                 <a:extLst>
                   <a:ext uri="{0D108BD9-81ED-4DB2-BD59-A6C34878D82A}">
-                    <a16:rowId xmlns:a16="http://schemas.microsoft.com/office/drawing/2014/main" val="1447204732"/>
+                    <a16:rowId xmlns:a16="http://schemas.microsoft.com/office/drawing/2014/main" val="1682819144"/>
                   </a:ext>
                 </a:extLst>
               </a:tr>
@@ -7038,7 +7038,7 @@
                 </a:tc>
                 <a:extLst>
                   <a:ext uri="{0D108BD9-81ED-4DB2-BD59-A6C34878D82A}">
-                    <a16:rowId xmlns:a16="http://schemas.microsoft.com/office/drawing/2014/main" val="3118751089"/>
+                    <a16:rowId xmlns:a16="http://schemas.microsoft.com/office/drawing/2014/main" val="772716796"/>
                   </a:ext>
                 </a:extLst>
               </a:tr>
@@ -7111,7 +7111,7 @@
                 </a:tc>
                 <a:extLst>
                   <a:ext uri="{0D108BD9-81ED-4DB2-BD59-A6C34878D82A}">
-                    <a16:rowId xmlns:a16="http://schemas.microsoft.com/office/drawing/2014/main" val="1864181050"/>
+                    <a16:rowId xmlns:a16="http://schemas.microsoft.com/office/drawing/2014/main" val="583090959"/>
                   </a:ext>
                 </a:extLst>
               </a:tr>
@@ -7124,7 +7124,7 @@
           <p:cNvPr id="5" name="TextBox 4">
             <a:extLst>
               <a:ext uri="{FF2B5EF4-FFF2-40B4-BE49-F238E27FC236}">
-                <a16:creationId xmlns:a16="http://schemas.microsoft.com/office/drawing/2014/main" id="{96DD812E-0C8B-E04A-CE69-D21455919237}"/>
+                <a16:creationId xmlns:a16="http://schemas.microsoft.com/office/drawing/2014/main" id="{F97B9AC8-2A51-A2C3-908A-38C8E6D702FE}"/>
               </a:ext>
             </a:extLst>
           </p:cNvPr>
@@ -7189,7 +7189,7 @@
     </p:spTree>
     <p:extLst>
       <p:ext uri="{BB962C8B-B14F-4D97-AF65-F5344CB8AC3E}">
-        <p14:creationId xmlns:p14="http://schemas.microsoft.com/office/powerpoint/2010/main" val="3137212572"/>
+        <p14:creationId xmlns:p14="http://schemas.microsoft.com/office/powerpoint/2010/main" val="2787760732"/>
       </p:ext>
     </p:extLst>
   </p:cSld>
@@ -7229,7 +7229,7 @@
           <p:cNvPr id="2" name="TextBox 1">
             <a:extLst>
               <a:ext uri="{FF2B5EF4-FFF2-40B4-BE49-F238E27FC236}">
-                <a16:creationId xmlns:a16="http://schemas.microsoft.com/office/drawing/2014/main" id="{D7D810F2-87A9-FCBA-55CF-66C3AA136AC9}"/>
+                <a16:creationId xmlns:a16="http://schemas.microsoft.com/office/drawing/2014/main" id="{5C80B3C8-5E24-34D3-1035-3B18C518318C}"/>
               </a:ext>
             </a:extLst>
           </p:cNvPr>
@@ -7280,7 +7280,7 @@
           <p:cNvPr id="3" name="TextBox 2">
             <a:extLst>
               <a:ext uri="{FF2B5EF4-FFF2-40B4-BE49-F238E27FC236}">
-                <a16:creationId xmlns:a16="http://schemas.microsoft.com/office/drawing/2014/main" id="{C56F131D-B3E7-CBB0-E108-869A4094E224}"/>
+                <a16:creationId xmlns:a16="http://schemas.microsoft.com/office/drawing/2014/main" id="{F18D7685-7D2F-6F57-9B6B-E0A8C7698EE7}"/>
               </a:ext>
             </a:extLst>
           </p:cNvPr>
@@ -7325,7 +7325,7 @@
           <p:cNvPr id="4" name="Table 3">
             <a:extLst>
               <a:ext uri="{FF2B5EF4-FFF2-40B4-BE49-F238E27FC236}">
-                <a16:creationId xmlns:a16="http://schemas.microsoft.com/office/drawing/2014/main" id="{BA03F2F7-6CC1-2BD4-4576-08131BAB5A1F}"/>
+                <a16:creationId xmlns:a16="http://schemas.microsoft.com/office/drawing/2014/main" id="{934043B3-5CDB-4A75-0A36-7C6D81721485}"/>
               </a:ext>
             </a:extLst>
           </p:cNvPr>
@@ -7335,7 +7335,7 @@
           <p:nvPr>
             <p:extLst>
               <p:ext uri="{D42A27DB-BD31-4B8C-83A1-F6EECF244321}">
-                <p14:modId xmlns:p14="http://schemas.microsoft.com/office/powerpoint/2010/main" val="1325382955"/>
+                <p14:modId xmlns:p14="http://schemas.microsoft.com/office/powerpoint/2010/main" val="1201038692"/>
               </p:ext>
             </p:extLst>
           </p:nvPr>
@@ -7354,28 +7354,28 @@
                 <a:gridCol w="2698750">
                   <a:extLst>
                     <a:ext uri="{9D8B030D-6E8A-4147-A177-3AD203B41FA5}">
-                      <a16:colId xmlns:a16="http://schemas.microsoft.com/office/drawing/2014/main" val="3452206427"/>
+                      <a16:colId xmlns:a16="http://schemas.microsoft.com/office/drawing/2014/main" val="2673180330"/>
                     </a:ext>
                   </a:extLst>
                 </a:gridCol>
                 <a:gridCol w="2698750">
                   <a:extLst>
                     <a:ext uri="{9D8B030D-6E8A-4147-A177-3AD203B41FA5}">
-                      <a16:colId xmlns:a16="http://schemas.microsoft.com/office/drawing/2014/main" val="366672558"/>
+                      <a16:colId xmlns:a16="http://schemas.microsoft.com/office/drawing/2014/main" val="2749713761"/>
                     </a:ext>
                   </a:extLst>
                 </a:gridCol>
                 <a:gridCol w="2698750">
                   <a:extLst>
                     <a:ext uri="{9D8B030D-6E8A-4147-A177-3AD203B41FA5}">
-                      <a16:colId xmlns:a16="http://schemas.microsoft.com/office/drawing/2014/main" val="645480831"/>
+                      <a16:colId xmlns:a16="http://schemas.microsoft.com/office/drawing/2014/main" val="2711467531"/>
                     </a:ext>
                   </a:extLst>
                 </a:gridCol>
                 <a:gridCol w="2698750">
                   <a:extLst>
                     <a:ext uri="{9D8B030D-6E8A-4147-A177-3AD203B41FA5}">
-                      <a16:colId xmlns:a16="http://schemas.microsoft.com/office/drawing/2014/main" val="322404146"/>
+                      <a16:colId xmlns:a16="http://schemas.microsoft.com/office/drawing/2014/main" val="1254541833"/>
                     </a:ext>
                   </a:extLst>
                 </a:gridCol>
@@ -7471,7 +7471,7 @@
                 </a:tc>
                 <a:extLst>
                   <a:ext uri="{0D108BD9-81ED-4DB2-BD59-A6C34878D82A}">
-                    <a16:rowId xmlns:a16="http://schemas.microsoft.com/office/drawing/2014/main" val="514333653"/>
+                    <a16:rowId xmlns:a16="http://schemas.microsoft.com/office/drawing/2014/main" val="998053210"/>
                   </a:ext>
                 </a:extLst>
               </a:tr>
@@ -7566,7 +7566,7 @@
                 </a:tc>
                 <a:extLst>
                   <a:ext uri="{0D108BD9-81ED-4DB2-BD59-A6C34878D82A}">
-                    <a16:rowId xmlns:a16="http://schemas.microsoft.com/office/drawing/2014/main" val="386627061"/>
+                    <a16:rowId xmlns:a16="http://schemas.microsoft.com/office/drawing/2014/main" val="612140240"/>
                   </a:ext>
                 </a:extLst>
               </a:tr>
@@ -7661,7 +7661,7 @@
                 </a:tc>
                 <a:extLst>
                   <a:ext uri="{0D108BD9-81ED-4DB2-BD59-A6C34878D82A}">
-                    <a16:rowId xmlns:a16="http://schemas.microsoft.com/office/drawing/2014/main" val="1539722850"/>
+                    <a16:rowId xmlns:a16="http://schemas.microsoft.com/office/drawing/2014/main" val="2142678897"/>
                   </a:ext>
                 </a:extLst>
               </a:tr>
@@ -7756,7 +7756,7 @@
                 </a:tc>
                 <a:extLst>
                   <a:ext uri="{0D108BD9-81ED-4DB2-BD59-A6C34878D82A}">
-                    <a16:rowId xmlns:a16="http://schemas.microsoft.com/office/drawing/2014/main" val="1760573"/>
+                    <a16:rowId xmlns:a16="http://schemas.microsoft.com/office/drawing/2014/main" val="733429046"/>
                   </a:ext>
                 </a:extLst>
               </a:tr>
@@ -7769,7 +7769,7 @@
           <p:cNvPr id="5" name="TextBox 4">
             <a:extLst>
               <a:ext uri="{FF2B5EF4-FFF2-40B4-BE49-F238E27FC236}">
-                <a16:creationId xmlns:a16="http://schemas.microsoft.com/office/drawing/2014/main" id="{79DE5E89-D7C4-0028-397A-50683C04913E}"/>
+                <a16:creationId xmlns:a16="http://schemas.microsoft.com/office/drawing/2014/main" id="{6FBCDE3C-24E3-7DCD-334D-1C270FC96975}"/>
               </a:ext>
             </a:extLst>
           </p:cNvPr>
@@ -7812,7 +7812,7 @@
     </p:spTree>
     <p:extLst>
       <p:ext uri="{BB962C8B-B14F-4D97-AF65-F5344CB8AC3E}">
-        <p14:creationId xmlns:p14="http://schemas.microsoft.com/office/powerpoint/2010/main" val="2027973303"/>
+        <p14:creationId xmlns:p14="http://schemas.microsoft.com/office/powerpoint/2010/main" val="3035370681"/>
       </p:ext>
     </p:extLst>
   </p:cSld>
@@ -7852,7 +7852,7 @@
           <p:cNvPr id="2" name="TextBox 1">
             <a:extLst>
               <a:ext uri="{FF2B5EF4-FFF2-40B4-BE49-F238E27FC236}">
-                <a16:creationId xmlns:a16="http://schemas.microsoft.com/office/drawing/2014/main" id="{0D054424-E5DC-3D2B-8A9A-9E2F784F8E1D}"/>
+                <a16:creationId xmlns:a16="http://schemas.microsoft.com/office/drawing/2014/main" id="{E58ADEFB-D4A8-AA37-3642-4EA2F4F245F3}"/>
               </a:ext>
             </a:extLst>
           </p:cNvPr>
@@ -7897,7 +7897,7 @@
           <p:cNvPr id="3" name="TextBox 2">
             <a:extLst>
               <a:ext uri="{FF2B5EF4-FFF2-40B4-BE49-F238E27FC236}">
-                <a16:creationId xmlns:a16="http://schemas.microsoft.com/office/drawing/2014/main" id="{4E9884DB-E5A9-8D97-0DED-FD4670BFD8B0}"/>
+                <a16:creationId xmlns:a16="http://schemas.microsoft.com/office/drawing/2014/main" id="{98365250-8CA0-394F-0BFF-18C8C04D6569}"/>
               </a:ext>
             </a:extLst>
           </p:cNvPr>
@@ -7942,7 +7942,7 @@
           <p:cNvPr id="5" name="Picture 4">
             <a:extLst>
               <a:ext uri="{FF2B5EF4-FFF2-40B4-BE49-F238E27FC236}">
-                <a16:creationId xmlns:a16="http://schemas.microsoft.com/office/drawing/2014/main" id="{1C8B7DFE-EDEF-7C99-ADE6-4B9609464266}"/>
+                <a16:creationId xmlns:a16="http://schemas.microsoft.com/office/drawing/2014/main" id="{F596597B-937E-70D1-2EF6-621444562436}"/>
               </a:ext>
             </a:extLst>
           </p:cNvPr>
@@ -7978,7 +7978,7 @@
           <p:cNvPr id="6" name="TextBox 5">
             <a:extLst>
               <a:ext uri="{FF2B5EF4-FFF2-40B4-BE49-F238E27FC236}">
-                <a16:creationId xmlns:a16="http://schemas.microsoft.com/office/drawing/2014/main" id="{AA1F86C8-1C97-CB0C-B8F4-F4012A1084BF}"/>
+                <a16:creationId xmlns:a16="http://schemas.microsoft.com/office/drawing/2014/main" id="{C28CE8D5-D1DA-82D8-5CC2-3B25CB948230}"/>
               </a:ext>
             </a:extLst>
           </p:cNvPr>
@@ -8027,7 +8027,7 @@
     </p:spTree>
     <p:extLst>
       <p:ext uri="{BB962C8B-B14F-4D97-AF65-F5344CB8AC3E}">
-        <p14:creationId xmlns:p14="http://schemas.microsoft.com/office/powerpoint/2010/main" val="1912451159"/>
+        <p14:creationId xmlns:p14="http://schemas.microsoft.com/office/powerpoint/2010/main" val="1471565579"/>
       </p:ext>
     </p:extLst>
   </p:cSld>
@@ -8067,7 +8067,7 @@
           <p:cNvPr id="2" name="TextBox 1">
             <a:extLst>
               <a:ext uri="{FF2B5EF4-FFF2-40B4-BE49-F238E27FC236}">
-                <a16:creationId xmlns:a16="http://schemas.microsoft.com/office/drawing/2014/main" id="{71A846CC-1EFF-567C-646D-F909D6AF5E4A}"/>
+                <a16:creationId xmlns:a16="http://schemas.microsoft.com/office/drawing/2014/main" id="{8322FDDA-5CF3-A68B-E166-9E1B99672704}"/>
               </a:ext>
             </a:extLst>
           </p:cNvPr>
@@ -8112,7 +8112,7 @@
           <p:cNvPr id="3" name="TextBox 2">
             <a:extLst>
               <a:ext uri="{FF2B5EF4-FFF2-40B4-BE49-F238E27FC236}">
-                <a16:creationId xmlns:a16="http://schemas.microsoft.com/office/drawing/2014/main" id="{F6473B02-9621-C7BB-2AC4-2667A8B47502}"/>
+                <a16:creationId xmlns:a16="http://schemas.microsoft.com/office/drawing/2014/main" id="{B4E71B41-7A56-6B61-4E84-9A26A91D3416}"/>
               </a:ext>
             </a:extLst>
           </p:cNvPr>
@@ -8157,7 +8157,7 @@
           <p:cNvPr id="5" name="Picture 4">
             <a:extLst>
               <a:ext uri="{FF2B5EF4-FFF2-40B4-BE49-F238E27FC236}">
-                <a16:creationId xmlns:a16="http://schemas.microsoft.com/office/drawing/2014/main" id="{F38E9157-B82E-2D74-2319-C7E2D4B5F3FC}"/>
+                <a16:creationId xmlns:a16="http://schemas.microsoft.com/office/drawing/2014/main" id="{C612B830-4E33-4C5E-D6FC-EFDB159A7D2C}"/>
               </a:ext>
             </a:extLst>
           </p:cNvPr>
@@ -8193,7 +8193,7 @@
           <p:cNvPr id="6" name="TextBox 5">
             <a:extLst>
               <a:ext uri="{FF2B5EF4-FFF2-40B4-BE49-F238E27FC236}">
-                <a16:creationId xmlns:a16="http://schemas.microsoft.com/office/drawing/2014/main" id="{3DDA403A-4C4E-14E2-E254-73A70C9517A4}"/>
+                <a16:creationId xmlns:a16="http://schemas.microsoft.com/office/drawing/2014/main" id="{A89AB05B-B1B6-43A1-85EE-2E862792E960}"/>
               </a:ext>
             </a:extLst>
           </p:cNvPr>
@@ -8236,7 +8236,7 @@
     </p:spTree>
     <p:extLst>
       <p:ext uri="{BB962C8B-B14F-4D97-AF65-F5344CB8AC3E}">
-        <p14:creationId xmlns:p14="http://schemas.microsoft.com/office/powerpoint/2010/main" val="980250468"/>
+        <p14:creationId xmlns:p14="http://schemas.microsoft.com/office/powerpoint/2010/main" val="2797304682"/>
       </p:ext>
     </p:extLst>
   </p:cSld>
@@ -8276,7 +8276,7 @@
           <p:cNvPr id="2" name="TextBox 1">
             <a:extLst>
               <a:ext uri="{FF2B5EF4-FFF2-40B4-BE49-F238E27FC236}">
-                <a16:creationId xmlns:a16="http://schemas.microsoft.com/office/drawing/2014/main" id="{07F0E955-DC59-9836-2E23-10AAA5DB09AA}"/>
+                <a16:creationId xmlns:a16="http://schemas.microsoft.com/office/drawing/2014/main" id="{E3FD26E9-7AB0-4646-3BE5-C65C1EAE2ABE}"/>
               </a:ext>
             </a:extLst>
           </p:cNvPr>
@@ -8321,7 +8321,7 @@
           <p:cNvPr id="3" name="TextBox 2">
             <a:extLst>
               <a:ext uri="{FF2B5EF4-FFF2-40B4-BE49-F238E27FC236}">
-                <a16:creationId xmlns:a16="http://schemas.microsoft.com/office/drawing/2014/main" id="{784A8EF0-C582-E64A-5F6C-EAB62B412836}"/>
+                <a16:creationId xmlns:a16="http://schemas.microsoft.com/office/drawing/2014/main" id="{9379CB5B-917E-FF5E-3F67-78C25CE33C17}"/>
               </a:ext>
             </a:extLst>
           </p:cNvPr>
@@ -8366,7 +8366,7 @@
           <p:cNvPr id="4" name="Table 3">
             <a:extLst>
               <a:ext uri="{FF2B5EF4-FFF2-40B4-BE49-F238E27FC236}">
-                <a16:creationId xmlns:a16="http://schemas.microsoft.com/office/drawing/2014/main" id="{E89818AE-5431-4F7C-CB78-FFB4006D20B2}"/>
+                <a16:creationId xmlns:a16="http://schemas.microsoft.com/office/drawing/2014/main" id="{F1A5BC31-87D5-F62D-5105-736D7CACF80D}"/>
               </a:ext>
             </a:extLst>
           </p:cNvPr>
@@ -8376,7 +8376,7 @@
           <p:nvPr>
             <p:extLst>
               <p:ext uri="{D42A27DB-BD31-4B8C-83A1-F6EECF244321}">
-                <p14:modId xmlns:p14="http://schemas.microsoft.com/office/powerpoint/2010/main" val="40404077"/>
+                <p14:modId xmlns:p14="http://schemas.microsoft.com/office/powerpoint/2010/main" val="1250854345"/>
               </p:ext>
             </p:extLst>
           </p:nvPr>
@@ -8395,14 +8395,14 @@
                 <a:gridCol w="5397500">
                   <a:extLst>
                     <a:ext uri="{9D8B030D-6E8A-4147-A177-3AD203B41FA5}">
-                      <a16:colId xmlns:a16="http://schemas.microsoft.com/office/drawing/2014/main" val="3356684136"/>
+                      <a16:colId xmlns:a16="http://schemas.microsoft.com/office/drawing/2014/main" val="39297748"/>
                     </a:ext>
                   </a:extLst>
                 </a:gridCol>
                 <a:gridCol w="5397500">
                   <a:extLst>
                     <a:ext uri="{9D8B030D-6E8A-4147-A177-3AD203B41FA5}">
-                      <a16:colId xmlns:a16="http://schemas.microsoft.com/office/drawing/2014/main" val="3946608386"/>
+                      <a16:colId xmlns:a16="http://schemas.microsoft.com/office/drawing/2014/main" val="1875557558"/>
                     </a:ext>
                   </a:extLst>
                 </a:gridCol>
@@ -8454,7 +8454,7 @@
                 </a:tc>
                 <a:extLst>
                   <a:ext uri="{0D108BD9-81ED-4DB2-BD59-A6C34878D82A}">
-                    <a16:rowId xmlns:a16="http://schemas.microsoft.com/office/drawing/2014/main" val="3001897984"/>
+                    <a16:rowId xmlns:a16="http://schemas.microsoft.com/office/drawing/2014/main" val="156044014"/>
                   </a:ext>
                 </a:extLst>
               </a:tr>
@@ -8505,7 +8505,7 @@
                 </a:tc>
                 <a:extLst>
                   <a:ext uri="{0D108BD9-81ED-4DB2-BD59-A6C34878D82A}">
-                    <a16:rowId xmlns:a16="http://schemas.microsoft.com/office/drawing/2014/main" val="2691127078"/>
+                    <a16:rowId xmlns:a16="http://schemas.microsoft.com/office/drawing/2014/main" val="627412416"/>
                   </a:ext>
                 </a:extLst>
               </a:tr>
@@ -8556,7 +8556,7 @@
                 </a:tc>
                 <a:extLst>
                   <a:ext uri="{0D108BD9-81ED-4DB2-BD59-A6C34878D82A}">
-                    <a16:rowId xmlns:a16="http://schemas.microsoft.com/office/drawing/2014/main" val="3271671239"/>
+                    <a16:rowId xmlns:a16="http://schemas.microsoft.com/office/drawing/2014/main" val="3711578370"/>
                   </a:ext>
                 </a:extLst>
               </a:tr>
@@ -8607,7 +8607,7 @@
                 </a:tc>
                 <a:extLst>
                   <a:ext uri="{0D108BD9-81ED-4DB2-BD59-A6C34878D82A}">
-                    <a16:rowId xmlns:a16="http://schemas.microsoft.com/office/drawing/2014/main" val="4114665549"/>
+                    <a16:rowId xmlns:a16="http://schemas.microsoft.com/office/drawing/2014/main" val="2037543175"/>
                   </a:ext>
                 </a:extLst>
               </a:tr>
@@ -8658,7 +8658,7 @@
                 </a:tc>
                 <a:extLst>
                   <a:ext uri="{0D108BD9-81ED-4DB2-BD59-A6C34878D82A}">
-                    <a16:rowId xmlns:a16="http://schemas.microsoft.com/office/drawing/2014/main" val="1467605860"/>
+                    <a16:rowId xmlns:a16="http://schemas.microsoft.com/office/drawing/2014/main" val="3863305524"/>
                   </a:ext>
                 </a:extLst>
               </a:tr>
@@ -8715,7 +8715,7 @@
                 </a:tc>
                 <a:extLst>
                   <a:ext uri="{0D108BD9-81ED-4DB2-BD59-A6C34878D82A}">
-                    <a16:rowId xmlns:a16="http://schemas.microsoft.com/office/drawing/2014/main" val="485734572"/>
+                    <a16:rowId xmlns:a16="http://schemas.microsoft.com/office/drawing/2014/main" val="1369801294"/>
                   </a:ext>
                 </a:extLst>
               </a:tr>
@@ -8728,7 +8728,7 @@
           <p:cNvPr id="5" name="TextBox 4">
             <a:extLst>
               <a:ext uri="{FF2B5EF4-FFF2-40B4-BE49-F238E27FC236}">
-                <a16:creationId xmlns:a16="http://schemas.microsoft.com/office/drawing/2014/main" id="{E0E52E52-7C78-504F-BBF0-E647C0507678}"/>
+                <a16:creationId xmlns:a16="http://schemas.microsoft.com/office/drawing/2014/main" id="{9715FCD7-E1DF-BFF8-258C-B36F7BE531FB}"/>
               </a:ext>
             </a:extLst>
           </p:cNvPr>
@@ -8777,7 +8777,7 @@
     </p:spTree>
     <p:extLst>
       <p:ext uri="{BB962C8B-B14F-4D97-AF65-F5344CB8AC3E}">
-        <p14:creationId xmlns:p14="http://schemas.microsoft.com/office/powerpoint/2010/main" val="2510960600"/>
+        <p14:creationId xmlns:p14="http://schemas.microsoft.com/office/powerpoint/2010/main" val="3997651913"/>
       </p:ext>
     </p:extLst>
   </p:cSld>
@@ -8817,7 +8817,7 @@
           <p:cNvPr id="2" name="TextBox 1">
             <a:extLst>
               <a:ext uri="{FF2B5EF4-FFF2-40B4-BE49-F238E27FC236}">
-                <a16:creationId xmlns:a16="http://schemas.microsoft.com/office/drawing/2014/main" id="{65C30AAE-8CC3-D144-885C-CD1D383442D0}"/>
+                <a16:creationId xmlns:a16="http://schemas.microsoft.com/office/drawing/2014/main" id="{631CD294-639C-15FD-F2E6-0B9434539BD9}"/>
               </a:ext>
             </a:extLst>
           </p:cNvPr>
@@ -8862,7 +8862,7 @@
           <p:cNvPr id="3" name="TextBox 2">
             <a:extLst>
               <a:ext uri="{FF2B5EF4-FFF2-40B4-BE49-F238E27FC236}">
-                <a16:creationId xmlns:a16="http://schemas.microsoft.com/office/drawing/2014/main" id="{C3758EAF-FD94-D39F-897E-BA692F7A854B}"/>
+                <a16:creationId xmlns:a16="http://schemas.microsoft.com/office/drawing/2014/main" id="{0DAD5CB9-1179-893B-1E3C-558DF67B9C4A}"/>
               </a:ext>
             </a:extLst>
           </p:cNvPr>
@@ -8902,12 +8902,48 @@
           </a:p>
         </p:txBody>
       </p:sp>
-      <p:sp>
-        <p:nvSpPr>
-          <p:cNvPr id="4" name="TextBox 3">
-            <a:extLst>
-              <a:ext uri="{FF2B5EF4-FFF2-40B4-BE49-F238E27FC236}">
-                <a16:creationId xmlns:a16="http://schemas.microsoft.com/office/drawing/2014/main" id="{87A4CD45-9077-3215-1618-CA1BD19CD85A}"/>
+      <p:pic>
+        <p:nvPicPr>
+          <p:cNvPr id="5" name="Picture 4">
+            <a:extLst>
+              <a:ext uri="{FF2B5EF4-FFF2-40B4-BE49-F238E27FC236}">
+                <a16:creationId xmlns:a16="http://schemas.microsoft.com/office/drawing/2014/main" id="{B1FB4D03-CD46-E52C-3D89-797ECDFCCD59}"/>
+              </a:ext>
+            </a:extLst>
+          </p:cNvPr>
+          <p:cNvPicPr>
+            <a:picLocks noChangeAspect="1"/>
+          </p:cNvPicPr>
+          <p:nvPr/>
+        </p:nvPicPr>
+        <p:blipFill>
+          <a:blip r:embed="rId3">
+            <a:extLst>
+              <a:ext uri="{28A0092B-C50C-407E-A947-70E740481C1C}">
+                <a14:useLocalDpi xmlns:a14="http://schemas.microsoft.com/office/drawing/2010/main" val="0"/>
+              </a:ext>
+            </a:extLst>
+          </a:blip>
+          <a:stretch>
+            <a:fillRect/>
+          </a:stretch>
+        </p:blipFill>
+        <p:spPr>
+          <a:xfrm>
+            <a:off x="698500" y="1524000"/>
+            <a:ext cx="5316932" cy="4699000"/>
+          </a:xfrm>
+          <a:prstGeom prst="rect">
+            <a:avLst/>
+          </a:prstGeom>
+        </p:spPr>
+      </p:pic>
+      <p:sp>
+        <p:nvSpPr>
+          <p:cNvPr id="6" name="TextBox 5">
+            <a:extLst>
+              <a:ext uri="{FF2B5EF4-FFF2-40B4-BE49-F238E27FC236}">
+                <a16:creationId xmlns:a16="http://schemas.microsoft.com/office/drawing/2014/main" id="{E41A5E68-9FFD-D4FC-A7DE-A0A902A5FB79}"/>
               </a:ext>
             </a:extLst>
           </p:cNvPr>
@@ -8916,8 +8952,8 @@
         </p:nvSpPr>
         <p:spPr>
           <a:xfrm>
-            <a:off x="762000" y="1714500"/>
-            <a:ext cx="10604500" cy="353943"/>
+            <a:off x="6477000" y="1714500"/>
+            <a:ext cx="5016500" cy="307777"/>
           </a:xfrm>
           <a:prstGeom prst="rect">
             <a:avLst/>
@@ -8936,7 +8972,7 @@
               </a:spcAft>
             </a:pPr>
             <a:r>
-              <a:rPr lang="en-US" sz="2300">
+              <a:rPr lang="en-US" sz="2000">
                 <a:solidFill>
                   <a:srgbClr val="485767"/>
                 </a:solidFill>
@@ -8949,10 +8985,10 @@
       </p:sp>
       <p:sp>
         <p:nvSpPr>
-          <p:cNvPr id="5" name="TextBox 4">
-            <a:extLst>
-              <a:ext uri="{FF2B5EF4-FFF2-40B4-BE49-F238E27FC236}">
-                <a16:creationId xmlns:a16="http://schemas.microsoft.com/office/drawing/2014/main" id="{AB00897A-5D75-BA9E-60A8-762F50249841}"/>
+          <p:cNvPr id="7" name="TextBox 6">
+            <a:extLst>
+              <a:ext uri="{FF2B5EF4-FFF2-40B4-BE49-F238E27FC236}">
+                <a16:creationId xmlns:a16="http://schemas.microsoft.com/office/drawing/2014/main" id="{2CEC00BC-1CB0-D588-B82D-4218BD30ABCB}"/>
               </a:ext>
             </a:extLst>
           </p:cNvPr>
@@ -8961,8 +8997,8 @@
         </p:nvSpPr>
         <p:spPr>
           <a:xfrm>
-            <a:off x="762000" y="2806700"/>
-            <a:ext cx="10604500" cy="353943"/>
+            <a:off x="6477000" y="2794000"/>
+            <a:ext cx="5016500" cy="615553"/>
           </a:xfrm>
           <a:prstGeom prst="rect">
             <a:avLst/>
@@ -8981,7 +9017,7 @@
               </a:spcAft>
             </a:pPr>
             <a:r>
-              <a:rPr lang="vi-VN" sz="2300">
+              <a:rPr lang="vi-VN" sz="2000">
                 <a:solidFill>
                   <a:srgbClr val="485767"/>
                 </a:solidFill>
@@ -8989,7 +9025,7 @@
               </a:rPr>
               <a:t>Quan sát cVAE xanh lá và Gaussian xanh dương trên cùng trục 0–8 giây.</a:t>
             </a:r>
-            <a:endParaRPr lang="en-US" sz="2300">
+            <a:endParaRPr lang="en-US" sz="2000">
               <a:solidFill>
                 <a:srgbClr val="485767"/>
               </a:solidFill>
@@ -9000,10 +9036,10 @@
       </p:sp>
       <p:sp>
         <p:nvSpPr>
-          <p:cNvPr id="6" name="TextBox 5">
-            <a:extLst>
-              <a:ext uri="{FF2B5EF4-FFF2-40B4-BE49-F238E27FC236}">
-                <a16:creationId xmlns:a16="http://schemas.microsoft.com/office/drawing/2014/main" id="{CF786F70-2670-FF28-4E93-E1D33BDE2C0B}"/>
+          <p:cNvPr id="8" name="TextBox 7">
+            <a:extLst>
+              <a:ext uri="{FF2B5EF4-FFF2-40B4-BE49-F238E27FC236}">
+                <a16:creationId xmlns:a16="http://schemas.microsoft.com/office/drawing/2014/main" id="{DF2F168D-D2B0-7239-A2C4-91378A9E6259}"/>
               </a:ext>
             </a:extLst>
           </p:cNvPr>
@@ -9012,8 +9048,8 @@
         </p:nvSpPr>
         <p:spPr>
           <a:xfrm>
-            <a:off x="762000" y="3898900"/>
-            <a:ext cx="10604500" cy="353943"/>
+            <a:off x="6477000" y="3873500"/>
+            <a:ext cx="5016500" cy="615553"/>
           </a:xfrm>
           <a:prstGeom prst="rect">
             <a:avLst/>
@@ -9032,7 +9068,7 @@
               </a:spcAft>
             </a:pPr>
             <a:r>
-              <a:rPr lang="en-US" sz="2300">
+              <a:rPr lang="en-US" sz="2000">
                 <a:solidFill>
                   <a:srgbClr val="485767"/>
                 </a:solidFill>
@@ -9045,10 +9081,10 @@
       </p:sp>
       <p:sp>
         <p:nvSpPr>
-          <p:cNvPr id="7" name="TextBox 6">
-            <a:extLst>
-              <a:ext uri="{FF2B5EF4-FFF2-40B4-BE49-F238E27FC236}">
-                <a16:creationId xmlns:a16="http://schemas.microsoft.com/office/drawing/2014/main" id="{27F7BFAB-E239-12BC-DA48-9F3B9661F0EA}"/>
+          <p:cNvPr id="9" name="TextBox 8">
+            <a:extLst>
+              <a:ext uri="{FF2B5EF4-FFF2-40B4-BE49-F238E27FC236}">
+                <a16:creationId xmlns:a16="http://schemas.microsoft.com/office/drawing/2014/main" id="{E4014780-D8E3-F4DA-1417-75AB79D34B0F}"/>
               </a:ext>
             </a:extLst>
           </p:cNvPr>
@@ -9057,8 +9093,8 @@
         </p:nvSpPr>
         <p:spPr>
           <a:xfrm>
-            <a:off x="762000" y="4991100"/>
-            <a:ext cx="10604500" cy="353943"/>
+            <a:off x="6477000" y="4953000"/>
+            <a:ext cx="5016500" cy="615553"/>
           </a:xfrm>
           <a:prstGeom prst="rect">
             <a:avLst/>
@@ -9077,7 +9113,7 @@
               </a:spcAft>
             </a:pPr>
             <a:r>
-              <a:rPr lang="en-US" sz="2300">
+              <a:rPr lang="en-US" sz="2000">
                 <a:solidFill>
                   <a:srgbClr val="485767"/>
                 </a:solidFill>
@@ -9091,7 +9127,7 @@
     </p:spTree>
     <p:extLst>
       <p:ext uri="{BB962C8B-B14F-4D97-AF65-F5344CB8AC3E}">
-        <p14:creationId xmlns:p14="http://schemas.microsoft.com/office/powerpoint/2010/main" val="2595762336"/>
+        <p14:creationId xmlns:p14="http://schemas.microsoft.com/office/powerpoint/2010/main" val="3942013455"/>
       </p:ext>
     </p:extLst>
   </p:cSld>
@@ -9131,7 +9167,7 @@
           <p:cNvPr id="2" name="TextBox 1">
             <a:extLst>
               <a:ext uri="{FF2B5EF4-FFF2-40B4-BE49-F238E27FC236}">
-                <a16:creationId xmlns:a16="http://schemas.microsoft.com/office/drawing/2014/main" id="{40D63125-36C0-9150-1043-DD75CBFFD9AA}"/>
+                <a16:creationId xmlns:a16="http://schemas.microsoft.com/office/drawing/2014/main" id="{14795B48-DC67-CA94-4F9C-828229D77290}"/>
               </a:ext>
             </a:extLst>
           </p:cNvPr>
@@ -9176,7 +9212,7 @@
           <p:cNvPr id="3" name="TextBox 2">
             <a:extLst>
               <a:ext uri="{FF2B5EF4-FFF2-40B4-BE49-F238E27FC236}">
-                <a16:creationId xmlns:a16="http://schemas.microsoft.com/office/drawing/2014/main" id="{524F5FEB-C99F-C351-F68A-085ABDC661E4}"/>
+                <a16:creationId xmlns:a16="http://schemas.microsoft.com/office/drawing/2014/main" id="{372ABC58-B00C-0106-D136-A072362F41BC}"/>
               </a:ext>
             </a:extLst>
           </p:cNvPr>
@@ -9221,7 +9257,7 @@
           <p:cNvPr id="5" name="Picture 4">
             <a:extLst>
               <a:ext uri="{FF2B5EF4-FFF2-40B4-BE49-F238E27FC236}">
-                <a16:creationId xmlns:a16="http://schemas.microsoft.com/office/drawing/2014/main" id="{0623E068-9C4F-2897-D9A5-00A51D1ACF48}"/>
+                <a16:creationId xmlns:a16="http://schemas.microsoft.com/office/drawing/2014/main" id="{031C3743-C2D3-9739-FF02-F0BA0553BC22}"/>
               </a:ext>
             </a:extLst>
           </p:cNvPr>
@@ -9257,7 +9293,7 @@
           <p:cNvPr id="6" name="TextBox 5">
             <a:extLst>
               <a:ext uri="{FF2B5EF4-FFF2-40B4-BE49-F238E27FC236}">
-                <a16:creationId xmlns:a16="http://schemas.microsoft.com/office/drawing/2014/main" id="{70D5BCCE-AA03-9FAE-8CA1-19916933AF6C}"/>
+                <a16:creationId xmlns:a16="http://schemas.microsoft.com/office/drawing/2014/main" id="{59B8437B-8B09-583C-33CA-F8DD99134D57}"/>
               </a:ext>
             </a:extLst>
           </p:cNvPr>
@@ -9300,7 +9336,7 @@
     </p:spTree>
     <p:extLst>
       <p:ext uri="{BB962C8B-B14F-4D97-AF65-F5344CB8AC3E}">
-        <p14:creationId xmlns:p14="http://schemas.microsoft.com/office/powerpoint/2010/main" val="3460160565"/>
+        <p14:creationId xmlns:p14="http://schemas.microsoft.com/office/powerpoint/2010/main" val="3822844607"/>
       </p:ext>
     </p:extLst>
   </p:cSld>
@@ -9340,7 +9376,7 @@
           <p:cNvPr id="2" name="TextBox 1">
             <a:extLst>
               <a:ext uri="{FF2B5EF4-FFF2-40B4-BE49-F238E27FC236}">
-                <a16:creationId xmlns:a16="http://schemas.microsoft.com/office/drawing/2014/main" id="{B6CC5A68-1DE8-96EC-566F-A017241C8EB1}"/>
+                <a16:creationId xmlns:a16="http://schemas.microsoft.com/office/drawing/2014/main" id="{BE0D72E2-8565-B27A-F95B-64D48F9ED0D3}"/>
               </a:ext>
             </a:extLst>
           </p:cNvPr>
@@ -9385,7 +9421,7 @@
           <p:cNvPr id="3" name="TextBox 2">
             <a:extLst>
               <a:ext uri="{FF2B5EF4-FFF2-40B4-BE49-F238E27FC236}">
-                <a16:creationId xmlns:a16="http://schemas.microsoft.com/office/drawing/2014/main" id="{7C13D61F-E6D2-ABAA-D32A-B2109346452C}"/>
+                <a16:creationId xmlns:a16="http://schemas.microsoft.com/office/drawing/2014/main" id="{AA1C736F-D479-CE21-C21F-1D93F33C5428}"/>
               </a:ext>
             </a:extLst>
           </p:cNvPr>
@@ -9430,7 +9466,7 @@
           <p:cNvPr id="4" name="TextBox 3">
             <a:extLst>
               <a:ext uri="{FF2B5EF4-FFF2-40B4-BE49-F238E27FC236}">
-                <a16:creationId xmlns:a16="http://schemas.microsoft.com/office/drawing/2014/main" id="{61EEA8AB-2523-B5BE-13D3-97B20C60D09F}"/>
+                <a16:creationId xmlns:a16="http://schemas.microsoft.com/office/drawing/2014/main" id="{C79000E9-B879-B358-D5EA-E94CB2A53779}"/>
               </a:ext>
             </a:extLst>
           </p:cNvPr>
@@ -9475,7 +9511,7 @@
           <p:cNvPr id="5" name="TextBox 4">
             <a:extLst>
               <a:ext uri="{FF2B5EF4-FFF2-40B4-BE49-F238E27FC236}">
-                <a16:creationId xmlns:a16="http://schemas.microsoft.com/office/drawing/2014/main" id="{D9130734-A180-669C-E716-12362385339E}"/>
+                <a16:creationId xmlns:a16="http://schemas.microsoft.com/office/drawing/2014/main" id="{A09A9E1A-3845-216E-6144-43B6481BA756}"/>
               </a:ext>
             </a:extLst>
           </p:cNvPr>
@@ -9520,7 +9556,7 @@
           <p:cNvPr id="6" name="TextBox 5">
             <a:extLst>
               <a:ext uri="{FF2B5EF4-FFF2-40B4-BE49-F238E27FC236}">
-                <a16:creationId xmlns:a16="http://schemas.microsoft.com/office/drawing/2014/main" id="{2FE56375-ECD8-A122-011D-8750CAF69991}"/>
+                <a16:creationId xmlns:a16="http://schemas.microsoft.com/office/drawing/2014/main" id="{69172FD4-7BB6-BBAB-C867-59B167AA911C}"/>
               </a:ext>
             </a:extLst>
           </p:cNvPr>
@@ -9563,7 +9599,7 @@
     </p:spTree>
     <p:extLst>
       <p:ext uri="{BB962C8B-B14F-4D97-AF65-F5344CB8AC3E}">
-        <p14:creationId xmlns:p14="http://schemas.microsoft.com/office/powerpoint/2010/main" val="271395814"/>
+        <p14:creationId xmlns:p14="http://schemas.microsoft.com/office/powerpoint/2010/main" val="1716751129"/>
       </p:ext>
     </p:extLst>
   </p:cSld>
@@ -9603,7 +9639,7 @@
           <p:cNvPr id="2" name="TextBox 1">
             <a:extLst>
               <a:ext uri="{FF2B5EF4-FFF2-40B4-BE49-F238E27FC236}">
-                <a16:creationId xmlns:a16="http://schemas.microsoft.com/office/drawing/2014/main" id="{6C89E88D-8A22-2E9B-2E42-7DBD3544C70A}"/>
+                <a16:creationId xmlns:a16="http://schemas.microsoft.com/office/drawing/2014/main" id="{69CD61D0-A6D7-46E7-B94D-B9B24F2D5754}"/>
               </a:ext>
             </a:extLst>
           </p:cNvPr>
@@ -9654,7 +9690,7 @@
           <p:cNvPr id="3" name="TextBox 2">
             <a:extLst>
               <a:ext uri="{FF2B5EF4-FFF2-40B4-BE49-F238E27FC236}">
-                <a16:creationId xmlns:a16="http://schemas.microsoft.com/office/drawing/2014/main" id="{4C31C7DE-464D-3C80-A6F9-40A9F597AD4F}"/>
+                <a16:creationId xmlns:a16="http://schemas.microsoft.com/office/drawing/2014/main" id="{DDBFCA6C-4381-983D-996A-8DAEA2CFA8C9}"/>
               </a:ext>
             </a:extLst>
           </p:cNvPr>
@@ -9699,7 +9735,7 @@
           <p:cNvPr id="4" name="TextBox 3">
             <a:extLst>
               <a:ext uri="{FF2B5EF4-FFF2-40B4-BE49-F238E27FC236}">
-                <a16:creationId xmlns:a16="http://schemas.microsoft.com/office/drawing/2014/main" id="{423E08C0-E5DD-EA9D-0463-0571DE1E977B}"/>
+                <a16:creationId xmlns:a16="http://schemas.microsoft.com/office/drawing/2014/main" id="{D9B5EAAD-FBDC-C335-4F52-EBB7CC833ED2}"/>
               </a:ext>
             </a:extLst>
           </p:cNvPr>
@@ -9744,7 +9780,7 @@
           <p:cNvPr id="5" name="TextBox 4">
             <a:extLst>
               <a:ext uri="{FF2B5EF4-FFF2-40B4-BE49-F238E27FC236}">
-                <a16:creationId xmlns:a16="http://schemas.microsoft.com/office/drawing/2014/main" id="{8AB2F753-81D5-AF01-2282-9D2B23FF555E}"/>
+                <a16:creationId xmlns:a16="http://schemas.microsoft.com/office/drawing/2014/main" id="{43817700-6171-32B9-BAC7-BEDD358A610D}"/>
               </a:ext>
             </a:extLst>
           </p:cNvPr>
@@ -9795,7 +9831,7 @@
           <p:cNvPr id="6" name="TextBox 5">
             <a:extLst>
               <a:ext uri="{FF2B5EF4-FFF2-40B4-BE49-F238E27FC236}">
-                <a16:creationId xmlns:a16="http://schemas.microsoft.com/office/drawing/2014/main" id="{4916A816-0CCB-6226-F156-76AB74368F31}"/>
+                <a16:creationId xmlns:a16="http://schemas.microsoft.com/office/drawing/2014/main" id="{3393DC1E-D998-3FB4-314E-896646DA56DA}"/>
               </a:ext>
             </a:extLst>
           </p:cNvPr>
@@ -9840,7 +9876,7 @@
           <p:cNvPr id="7" name="TextBox 6">
             <a:extLst>
               <a:ext uri="{FF2B5EF4-FFF2-40B4-BE49-F238E27FC236}">
-                <a16:creationId xmlns:a16="http://schemas.microsoft.com/office/drawing/2014/main" id="{6D8F0C48-35D8-253B-515D-2F74CA1C48F9}"/>
+                <a16:creationId xmlns:a16="http://schemas.microsoft.com/office/drawing/2014/main" id="{2581B34E-34E8-3B0F-6FC0-4AEC0FA27341}"/>
               </a:ext>
             </a:extLst>
           </p:cNvPr>
@@ -9889,7 +9925,7 @@
     </p:spTree>
     <p:extLst>
       <p:ext uri="{BB962C8B-B14F-4D97-AF65-F5344CB8AC3E}">
-        <p14:creationId xmlns:p14="http://schemas.microsoft.com/office/powerpoint/2010/main" val="1855847252"/>
+        <p14:creationId xmlns:p14="http://schemas.microsoft.com/office/powerpoint/2010/main" val="1694741055"/>
       </p:ext>
     </p:extLst>
   </p:cSld>
@@ -9929,7 +9965,7 @@
           <p:cNvPr id="2" name="TextBox 1">
             <a:extLst>
               <a:ext uri="{FF2B5EF4-FFF2-40B4-BE49-F238E27FC236}">
-                <a16:creationId xmlns:a16="http://schemas.microsoft.com/office/drawing/2014/main" id="{F6BA68EC-AB55-3F06-DBF0-93886A063A14}"/>
+                <a16:creationId xmlns:a16="http://schemas.microsoft.com/office/drawing/2014/main" id="{AD6E1158-55CE-A98A-9E98-45121CA41B46}"/>
               </a:ext>
             </a:extLst>
           </p:cNvPr>
@@ -9974,7 +10010,7 @@
           <p:cNvPr id="3" name="TextBox 2">
             <a:extLst>
               <a:ext uri="{FF2B5EF4-FFF2-40B4-BE49-F238E27FC236}">
-                <a16:creationId xmlns:a16="http://schemas.microsoft.com/office/drawing/2014/main" id="{0822155C-7A26-5196-D35A-E21D5D58094B}"/>
+                <a16:creationId xmlns:a16="http://schemas.microsoft.com/office/drawing/2014/main" id="{1CA7C6A7-758E-03E8-A7E6-F542BBCDED98}"/>
               </a:ext>
             </a:extLst>
           </p:cNvPr>
@@ -10019,7 +10055,7 @@
           <p:cNvPr id="4" name="TextBox 3">
             <a:extLst>
               <a:ext uri="{FF2B5EF4-FFF2-40B4-BE49-F238E27FC236}">
-                <a16:creationId xmlns:a16="http://schemas.microsoft.com/office/drawing/2014/main" id="{9AAFA428-1646-254D-448B-AB9357EA106D}"/>
+                <a16:creationId xmlns:a16="http://schemas.microsoft.com/office/drawing/2014/main" id="{7CBF086D-B016-526B-7EB8-8E2E81DA832F}"/>
               </a:ext>
             </a:extLst>
           </p:cNvPr>
@@ -10064,7 +10100,7 @@
           <p:cNvPr id="5" name="TextBox 4">
             <a:extLst>
               <a:ext uri="{FF2B5EF4-FFF2-40B4-BE49-F238E27FC236}">
-                <a16:creationId xmlns:a16="http://schemas.microsoft.com/office/drawing/2014/main" id="{23A18DA0-EE26-682F-D6C9-75AA45BF30E3}"/>
+                <a16:creationId xmlns:a16="http://schemas.microsoft.com/office/drawing/2014/main" id="{832D0657-D4B6-730E-09DF-74566A9E6053}"/>
               </a:ext>
             </a:extLst>
           </p:cNvPr>
@@ -10109,7 +10145,7 @@
           <p:cNvPr id="6" name="TextBox 5">
             <a:extLst>
               <a:ext uri="{FF2B5EF4-FFF2-40B4-BE49-F238E27FC236}">
-                <a16:creationId xmlns:a16="http://schemas.microsoft.com/office/drawing/2014/main" id="{DDD6543A-7831-D5C2-4669-C5924716BCA8}"/>
+                <a16:creationId xmlns:a16="http://schemas.microsoft.com/office/drawing/2014/main" id="{1D3A1B8A-9458-FDF1-43A1-4BEDF38126C8}"/>
               </a:ext>
             </a:extLst>
           </p:cNvPr>
@@ -10154,7 +10190,7 @@
           <p:cNvPr id="7" name="TextBox 6">
             <a:extLst>
               <a:ext uri="{FF2B5EF4-FFF2-40B4-BE49-F238E27FC236}">
-                <a16:creationId xmlns:a16="http://schemas.microsoft.com/office/drawing/2014/main" id="{B9ADCC57-F048-8C6F-6786-4E9F21168983}"/>
+                <a16:creationId xmlns:a16="http://schemas.microsoft.com/office/drawing/2014/main" id="{C6555872-1CAB-D64F-6775-10099DA7C9BB}"/>
               </a:ext>
             </a:extLst>
           </p:cNvPr>
@@ -10197,7 +10233,7 @@
     </p:spTree>
     <p:extLst>
       <p:ext uri="{BB962C8B-B14F-4D97-AF65-F5344CB8AC3E}">
-        <p14:creationId xmlns:p14="http://schemas.microsoft.com/office/powerpoint/2010/main" val="1329941337"/>
+        <p14:creationId xmlns:p14="http://schemas.microsoft.com/office/powerpoint/2010/main" val="2414439752"/>
       </p:ext>
     </p:extLst>
   </p:cSld>
@@ -10237,7 +10273,7 @@
           <p:cNvPr id="2" name="TextBox 1">
             <a:extLst>
               <a:ext uri="{FF2B5EF4-FFF2-40B4-BE49-F238E27FC236}">
-                <a16:creationId xmlns:a16="http://schemas.microsoft.com/office/drawing/2014/main" id="{1DB8D650-DF89-AAFA-E062-6879884DE754}"/>
+                <a16:creationId xmlns:a16="http://schemas.microsoft.com/office/drawing/2014/main" id="{AE421AEB-B5CA-580E-4245-638C75D70EA9}"/>
               </a:ext>
             </a:extLst>
           </p:cNvPr>
@@ -10288,7 +10324,7 @@
           <p:cNvPr id="3" name="TextBox 2">
             <a:extLst>
               <a:ext uri="{FF2B5EF4-FFF2-40B4-BE49-F238E27FC236}">
-                <a16:creationId xmlns:a16="http://schemas.microsoft.com/office/drawing/2014/main" id="{5C84C968-DDCD-1A09-FA9E-9371E85330D7}"/>
+                <a16:creationId xmlns:a16="http://schemas.microsoft.com/office/drawing/2014/main" id="{2F33140D-F065-49AF-7296-EAC01245A592}"/>
               </a:ext>
             </a:extLst>
           </p:cNvPr>
@@ -10333,7 +10369,7 @@
           <p:cNvPr id="4" name="TextBox 3">
             <a:extLst>
               <a:ext uri="{FF2B5EF4-FFF2-40B4-BE49-F238E27FC236}">
-                <a16:creationId xmlns:a16="http://schemas.microsoft.com/office/drawing/2014/main" id="{6B9C945E-1C8E-A295-AC44-7413B8BF2C7B}"/>
+                <a16:creationId xmlns:a16="http://schemas.microsoft.com/office/drawing/2014/main" id="{1D1A7E5B-D511-4FFA-65BC-EEAF30BC8E93}"/>
               </a:ext>
             </a:extLst>
           </p:cNvPr>
@@ -10392,7 +10428,7 @@
     </p:spTree>
     <p:extLst>
       <p:ext uri="{BB962C8B-B14F-4D97-AF65-F5344CB8AC3E}">
-        <p14:creationId xmlns:p14="http://schemas.microsoft.com/office/powerpoint/2010/main" val="4151773313"/>
+        <p14:creationId xmlns:p14="http://schemas.microsoft.com/office/powerpoint/2010/main" val="928785013"/>
       </p:ext>
     </p:extLst>
   </p:cSld>
@@ -10432,7 +10468,7 @@
           <p:cNvPr id="2" name="TextBox 1">
             <a:extLst>
               <a:ext uri="{FF2B5EF4-FFF2-40B4-BE49-F238E27FC236}">
-                <a16:creationId xmlns:a16="http://schemas.microsoft.com/office/drawing/2014/main" id="{86D61BC8-6431-647A-B93F-F1BBFE4B5C62}"/>
+                <a16:creationId xmlns:a16="http://schemas.microsoft.com/office/drawing/2014/main" id="{9EFA79BF-E2FE-2D77-A1FF-373581853846}"/>
               </a:ext>
             </a:extLst>
           </p:cNvPr>
@@ -10477,7 +10513,7 @@
           <p:cNvPr id="3" name="TextBox 2">
             <a:extLst>
               <a:ext uri="{FF2B5EF4-FFF2-40B4-BE49-F238E27FC236}">
-                <a16:creationId xmlns:a16="http://schemas.microsoft.com/office/drawing/2014/main" id="{AF612754-C5A0-0F78-219E-EB22FD4CAC53}"/>
+                <a16:creationId xmlns:a16="http://schemas.microsoft.com/office/drawing/2014/main" id="{654652C4-52B1-9C59-CB4D-F98C7D073ED4}"/>
               </a:ext>
             </a:extLst>
           </p:cNvPr>
@@ -10522,7 +10558,7 @@
           <p:cNvPr id="5" name="Picture 4">
             <a:extLst>
               <a:ext uri="{FF2B5EF4-FFF2-40B4-BE49-F238E27FC236}">
-                <a16:creationId xmlns:a16="http://schemas.microsoft.com/office/drawing/2014/main" id="{665E8E60-5C6E-8323-174D-B539EF257C88}"/>
+                <a16:creationId xmlns:a16="http://schemas.microsoft.com/office/drawing/2014/main" id="{E1A9AB2C-2A05-5B35-E204-39193A8F6AAF}"/>
               </a:ext>
             </a:extLst>
           </p:cNvPr>
@@ -10558,7 +10594,7 @@
           <p:cNvPr id="6" name="TextBox 5">
             <a:extLst>
               <a:ext uri="{FF2B5EF4-FFF2-40B4-BE49-F238E27FC236}">
-                <a16:creationId xmlns:a16="http://schemas.microsoft.com/office/drawing/2014/main" id="{FBAABA5A-E3D6-6D13-8746-E9231ED31836}"/>
+                <a16:creationId xmlns:a16="http://schemas.microsoft.com/office/drawing/2014/main" id="{54A61DE2-51D9-D0C4-EE07-F64242A43AB7}"/>
               </a:ext>
             </a:extLst>
           </p:cNvPr>
@@ -10601,7 +10637,7 @@
     </p:spTree>
     <p:extLst>
       <p:ext uri="{BB962C8B-B14F-4D97-AF65-F5344CB8AC3E}">
-        <p14:creationId xmlns:p14="http://schemas.microsoft.com/office/powerpoint/2010/main" val="4217881027"/>
+        <p14:creationId xmlns:p14="http://schemas.microsoft.com/office/powerpoint/2010/main" val="308731830"/>
       </p:ext>
     </p:extLst>
   </p:cSld>
@@ -10641,7 +10677,7 @@
           <p:cNvPr id="2" name="TextBox 1">
             <a:extLst>
               <a:ext uri="{FF2B5EF4-FFF2-40B4-BE49-F238E27FC236}">
-                <a16:creationId xmlns:a16="http://schemas.microsoft.com/office/drawing/2014/main" id="{7207E070-969A-BEAF-5E42-2F60B1371BD2}"/>
+                <a16:creationId xmlns:a16="http://schemas.microsoft.com/office/drawing/2014/main" id="{E32C9D90-3093-6A10-62CC-F8E37408E0FC}"/>
               </a:ext>
             </a:extLst>
           </p:cNvPr>
@@ -10686,7 +10722,7 @@
           <p:cNvPr id="3" name="TextBox 2">
             <a:extLst>
               <a:ext uri="{FF2B5EF4-FFF2-40B4-BE49-F238E27FC236}">
-                <a16:creationId xmlns:a16="http://schemas.microsoft.com/office/drawing/2014/main" id="{5B0CA415-4FC7-7CA7-456D-6AC79B3994CA}"/>
+                <a16:creationId xmlns:a16="http://schemas.microsoft.com/office/drawing/2014/main" id="{1E4CC336-7880-C034-0C25-3990DFD42EC4}"/>
               </a:ext>
             </a:extLst>
           </p:cNvPr>
@@ -10731,7 +10767,7 @@
           <p:cNvPr id="4" name="TextBox 3">
             <a:extLst>
               <a:ext uri="{FF2B5EF4-FFF2-40B4-BE49-F238E27FC236}">
-                <a16:creationId xmlns:a16="http://schemas.microsoft.com/office/drawing/2014/main" id="{1CE392EC-C160-06FB-3880-FF56A2A089C9}"/>
+                <a16:creationId xmlns:a16="http://schemas.microsoft.com/office/drawing/2014/main" id="{4AB45858-E4DE-1601-C379-2361F3E93B14}"/>
               </a:ext>
             </a:extLst>
           </p:cNvPr>
@@ -10782,7 +10818,7 @@
           <p:cNvPr id="5" name="TextBox 4">
             <a:extLst>
               <a:ext uri="{FF2B5EF4-FFF2-40B4-BE49-F238E27FC236}">
-                <a16:creationId xmlns:a16="http://schemas.microsoft.com/office/drawing/2014/main" id="{A4FF5A43-BD9F-9EE8-8339-2487F23F89A7}"/>
+                <a16:creationId xmlns:a16="http://schemas.microsoft.com/office/drawing/2014/main" id="{7802A941-C092-41BB-8776-83155B83E0ED}"/>
               </a:ext>
             </a:extLst>
           </p:cNvPr>
@@ -10833,7 +10869,7 @@
           <p:cNvPr id="6" name="TextBox 5">
             <a:extLst>
               <a:ext uri="{FF2B5EF4-FFF2-40B4-BE49-F238E27FC236}">
-                <a16:creationId xmlns:a16="http://schemas.microsoft.com/office/drawing/2014/main" id="{B05E8240-83B2-74F0-F1F7-B15A97F450BA}"/>
+                <a16:creationId xmlns:a16="http://schemas.microsoft.com/office/drawing/2014/main" id="{9B3EFE07-2F24-8BF3-78C1-3CA2FF29CD91}"/>
               </a:ext>
             </a:extLst>
           </p:cNvPr>
@@ -10882,7 +10918,7 @@
     </p:spTree>
     <p:extLst>
       <p:ext uri="{BB962C8B-B14F-4D97-AF65-F5344CB8AC3E}">
-        <p14:creationId xmlns:p14="http://schemas.microsoft.com/office/powerpoint/2010/main" val="1029725364"/>
+        <p14:creationId xmlns:p14="http://schemas.microsoft.com/office/powerpoint/2010/main" val="571341232"/>
       </p:ext>
     </p:extLst>
   </p:cSld>
@@ -10922,7 +10958,7 @@
           <p:cNvPr id="2" name="TextBox 1">
             <a:extLst>
               <a:ext uri="{FF2B5EF4-FFF2-40B4-BE49-F238E27FC236}">
-                <a16:creationId xmlns:a16="http://schemas.microsoft.com/office/drawing/2014/main" id="{860BFA69-10B8-E2FE-74FD-9E5CE3C662B5}"/>
+                <a16:creationId xmlns:a16="http://schemas.microsoft.com/office/drawing/2014/main" id="{64C1341E-FB77-C5F7-C40D-165C01172DC5}"/>
               </a:ext>
             </a:extLst>
           </p:cNvPr>
@@ -10973,7 +11009,7 @@
           <p:cNvPr id="3" name="TextBox 2">
             <a:extLst>
               <a:ext uri="{FF2B5EF4-FFF2-40B4-BE49-F238E27FC236}">
-                <a16:creationId xmlns:a16="http://schemas.microsoft.com/office/drawing/2014/main" id="{B6E1401F-935A-DCAE-8A32-51DA4B5AFD76}"/>
+                <a16:creationId xmlns:a16="http://schemas.microsoft.com/office/drawing/2014/main" id="{37B328C0-D017-92F5-574C-4F36DB991F46}"/>
               </a:ext>
             </a:extLst>
           </p:cNvPr>
@@ -11018,7 +11054,7 @@
           <p:cNvPr id="5" name="Picture 4">
             <a:extLst>
               <a:ext uri="{FF2B5EF4-FFF2-40B4-BE49-F238E27FC236}">
-                <a16:creationId xmlns:a16="http://schemas.microsoft.com/office/drawing/2014/main" id="{5F8A421D-F863-7825-A404-1CF91CDE4235}"/>
+                <a16:creationId xmlns:a16="http://schemas.microsoft.com/office/drawing/2014/main" id="{98F1BA53-251B-3192-F015-9F421B351CBF}"/>
               </a:ext>
             </a:extLst>
           </p:cNvPr>
@@ -11054,7 +11090,7 @@
           <p:cNvPr id="6" name="TextBox 5">
             <a:extLst>
               <a:ext uri="{FF2B5EF4-FFF2-40B4-BE49-F238E27FC236}">
-                <a16:creationId xmlns:a16="http://schemas.microsoft.com/office/drawing/2014/main" id="{69EFD962-3B93-A07E-0461-C7813A40308E}"/>
+                <a16:creationId xmlns:a16="http://schemas.microsoft.com/office/drawing/2014/main" id="{BCDF4FC8-0BA8-8089-B9B3-C0A9522D2659}"/>
               </a:ext>
             </a:extLst>
           </p:cNvPr>
@@ -11119,7 +11155,7 @@
     </p:spTree>
     <p:extLst>
       <p:ext uri="{BB962C8B-B14F-4D97-AF65-F5344CB8AC3E}">
-        <p14:creationId xmlns:p14="http://schemas.microsoft.com/office/powerpoint/2010/main" val="904206098"/>
+        <p14:creationId xmlns:p14="http://schemas.microsoft.com/office/powerpoint/2010/main" val="1593043544"/>
       </p:ext>
     </p:extLst>
   </p:cSld>
@@ -11159,7 +11195,7 @@
           <p:cNvPr id="2" name="TextBox 1">
             <a:extLst>
               <a:ext uri="{FF2B5EF4-FFF2-40B4-BE49-F238E27FC236}">
-                <a16:creationId xmlns:a16="http://schemas.microsoft.com/office/drawing/2014/main" id="{8548822F-EF08-3D52-950D-24341A4C63DC}"/>
+                <a16:creationId xmlns:a16="http://schemas.microsoft.com/office/drawing/2014/main" id="{A1EEFE35-CBFD-7597-6CC7-28AF26A3F202}"/>
               </a:ext>
             </a:extLst>
           </p:cNvPr>
@@ -11204,7 +11240,7 @@
           <p:cNvPr id="3" name="TextBox 2">
             <a:extLst>
               <a:ext uri="{FF2B5EF4-FFF2-40B4-BE49-F238E27FC236}">
-                <a16:creationId xmlns:a16="http://schemas.microsoft.com/office/drawing/2014/main" id="{F7D8CE09-5D53-8578-4CAF-317FCF4C0F7B}"/>
+                <a16:creationId xmlns:a16="http://schemas.microsoft.com/office/drawing/2014/main" id="{5D600602-B83B-2DAC-830B-4AD752CA6568}"/>
               </a:ext>
             </a:extLst>
           </p:cNvPr>
@@ -11249,7 +11285,7 @@
           <p:cNvPr id="4" name="TextBox 3">
             <a:extLst>
               <a:ext uri="{FF2B5EF4-FFF2-40B4-BE49-F238E27FC236}">
-                <a16:creationId xmlns:a16="http://schemas.microsoft.com/office/drawing/2014/main" id="{7F96CC98-31D8-2BDF-3A3D-E4D3A0498EB5}"/>
+                <a16:creationId xmlns:a16="http://schemas.microsoft.com/office/drawing/2014/main" id="{AD71F644-1013-3F0F-06A5-131D2ED2DEE8}"/>
               </a:ext>
             </a:extLst>
           </p:cNvPr>
@@ -11294,7 +11330,7 @@
           <p:cNvPr id="5" name="TextBox 4">
             <a:extLst>
               <a:ext uri="{FF2B5EF4-FFF2-40B4-BE49-F238E27FC236}">
-                <a16:creationId xmlns:a16="http://schemas.microsoft.com/office/drawing/2014/main" id="{AD24BC9A-ED05-70FC-B334-D3DC76129A7C}"/>
+                <a16:creationId xmlns:a16="http://schemas.microsoft.com/office/drawing/2014/main" id="{95A843A1-F0B8-79D5-5045-8A542B13CA87}"/>
               </a:ext>
             </a:extLst>
           </p:cNvPr>
@@ -11339,7 +11375,7 @@
           <p:cNvPr id="6" name="TextBox 5">
             <a:extLst>
               <a:ext uri="{FF2B5EF4-FFF2-40B4-BE49-F238E27FC236}">
-                <a16:creationId xmlns:a16="http://schemas.microsoft.com/office/drawing/2014/main" id="{D441009D-0BE3-A33B-A431-0282DD5B8CCD}"/>
+                <a16:creationId xmlns:a16="http://schemas.microsoft.com/office/drawing/2014/main" id="{51FBCBC6-E696-3579-FC2F-A0BFC10188B0}"/>
               </a:ext>
             </a:extLst>
           </p:cNvPr>
@@ -11384,7 +11420,7 @@
           <p:cNvPr id="7" name="TextBox 6">
             <a:extLst>
               <a:ext uri="{FF2B5EF4-FFF2-40B4-BE49-F238E27FC236}">
-                <a16:creationId xmlns:a16="http://schemas.microsoft.com/office/drawing/2014/main" id="{8175348D-88B1-37FB-16E9-89DE9EFD439B}"/>
+                <a16:creationId xmlns:a16="http://schemas.microsoft.com/office/drawing/2014/main" id="{31E70D3C-C947-D9FA-75D1-9031BBFDD20B}"/>
               </a:ext>
             </a:extLst>
           </p:cNvPr>
@@ -11427,7 +11463,7 @@
     </p:spTree>
     <p:extLst>
       <p:ext uri="{BB962C8B-B14F-4D97-AF65-F5344CB8AC3E}">
-        <p14:creationId xmlns:p14="http://schemas.microsoft.com/office/powerpoint/2010/main" val="518864455"/>
+        <p14:creationId xmlns:p14="http://schemas.microsoft.com/office/powerpoint/2010/main" val="752564399"/>
       </p:ext>
     </p:extLst>
   </p:cSld>
@@ -11467,7 +11503,7 @@
           <p:cNvPr id="2" name="TextBox 1">
             <a:extLst>
               <a:ext uri="{FF2B5EF4-FFF2-40B4-BE49-F238E27FC236}">
-                <a16:creationId xmlns:a16="http://schemas.microsoft.com/office/drawing/2014/main" id="{90C82590-120D-93DE-410A-AE00C96F9C6C}"/>
+                <a16:creationId xmlns:a16="http://schemas.microsoft.com/office/drawing/2014/main" id="{3A05AA91-D751-677B-EA5E-C6AE83B5F81E}"/>
               </a:ext>
             </a:extLst>
           </p:cNvPr>
@@ -11512,7 +11548,7 @@
           <p:cNvPr id="3" name="TextBox 2">
             <a:extLst>
               <a:ext uri="{FF2B5EF4-FFF2-40B4-BE49-F238E27FC236}">
-                <a16:creationId xmlns:a16="http://schemas.microsoft.com/office/drawing/2014/main" id="{26143CC6-87CC-7498-CB08-F4754E778977}"/>
+                <a16:creationId xmlns:a16="http://schemas.microsoft.com/office/drawing/2014/main" id="{C7D80B5C-59E3-03D8-0B60-AF2BE9477130}"/>
               </a:ext>
             </a:extLst>
           </p:cNvPr>
@@ -11557,7 +11593,7 @@
           <p:cNvPr id="5" name="Picture 4">
             <a:extLst>
               <a:ext uri="{FF2B5EF4-FFF2-40B4-BE49-F238E27FC236}">
-                <a16:creationId xmlns:a16="http://schemas.microsoft.com/office/drawing/2014/main" id="{883CF7E9-DA21-216B-3E34-7D05C4FE3ECF}"/>
+                <a16:creationId xmlns:a16="http://schemas.microsoft.com/office/drawing/2014/main" id="{47281BF4-8E75-5C3B-BB21-2B519CFD707A}"/>
               </a:ext>
             </a:extLst>
           </p:cNvPr>
@@ -11593,7 +11629,7 @@
           <p:cNvPr id="6" name="TextBox 5">
             <a:extLst>
               <a:ext uri="{FF2B5EF4-FFF2-40B4-BE49-F238E27FC236}">
-                <a16:creationId xmlns:a16="http://schemas.microsoft.com/office/drawing/2014/main" id="{07FCC76E-A039-88E0-F6FA-06ECD8E30489}"/>
+                <a16:creationId xmlns:a16="http://schemas.microsoft.com/office/drawing/2014/main" id="{24382590-008A-F406-B4C9-935B9C1E76D3}"/>
               </a:ext>
             </a:extLst>
           </p:cNvPr>
@@ -11636,7 +11672,7 @@
     </p:spTree>
     <p:extLst>
       <p:ext uri="{BB962C8B-B14F-4D97-AF65-F5344CB8AC3E}">
-        <p14:creationId xmlns:p14="http://schemas.microsoft.com/office/powerpoint/2010/main" val="2786739327"/>
+        <p14:creationId xmlns:p14="http://schemas.microsoft.com/office/powerpoint/2010/main" val="4218000223"/>
       </p:ext>
     </p:extLst>
   </p:cSld>
@@ -11676,7 +11712,7 @@
           <p:cNvPr id="2" name="TextBox 1">
             <a:extLst>
               <a:ext uri="{FF2B5EF4-FFF2-40B4-BE49-F238E27FC236}">
-                <a16:creationId xmlns:a16="http://schemas.microsoft.com/office/drawing/2014/main" id="{B3330E96-79D2-46F2-ADEC-23AE7E59BD78}"/>
+                <a16:creationId xmlns:a16="http://schemas.microsoft.com/office/drawing/2014/main" id="{32C1122C-E77D-0988-CA65-1E91268087FD}"/>
               </a:ext>
             </a:extLst>
           </p:cNvPr>
@@ -11721,7 +11757,7 @@
           <p:cNvPr id="3" name="TextBox 2">
             <a:extLst>
               <a:ext uri="{FF2B5EF4-FFF2-40B4-BE49-F238E27FC236}">
-                <a16:creationId xmlns:a16="http://schemas.microsoft.com/office/drawing/2014/main" id="{FB7B2DA9-4805-4F3C-549C-A79BB21CBBFE}"/>
+                <a16:creationId xmlns:a16="http://schemas.microsoft.com/office/drawing/2014/main" id="{2C34E7BA-B9F4-5834-EFB8-43EE9C44CC9C}"/>
               </a:ext>
             </a:extLst>
           </p:cNvPr>
@@ -11766,7 +11802,7 @@
           <p:cNvPr id="4" name="Table 3">
             <a:extLst>
               <a:ext uri="{FF2B5EF4-FFF2-40B4-BE49-F238E27FC236}">
-                <a16:creationId xmlns:a16="http://schemas.microsoft.com/office/drawing/2014/main" id="{BCD637B1-7825-CE11-C8AE-317E6B23D9B3}"/>
+                <a16:creationId xmlns:a16="http://schemas.microsoft.com/office/drawing/2014/main" id="{8D74E950-7ACF-6892-115B-7AAE40893704}"/>
               </a:ext>
             </a:extLst>
           </p:cNvPr>
@@ -11776,7 +11812,7 @@
           <p:nvPr>
             <p:extLst>
               <p:ext uri="{D42A27DB-BD31-4B8C-83A1-F6EECF244321}">
-                <p14:modId xmlns:p14="http://schemas.microsoft.com/office/powerpoint/2010/main" val="3613651752"/>
+                <p14:modId xmlns:p14="http://schemas.microsoft.com/office/powerpoint/2010/main" val="2164875027"/>
               </p:ext>
             </p:extLst>
           </p:nvPr>
@@ -11795,21 +11831,21 @@
                 <a:gridCol w="3598333">
                   <a:extLst>
                     <a:ext uri="{9D8B030D-6E8A-4147-A177-3AD203B41FA5}">
-                      <a16:colId xmlns:a16="http://schemas.microsoft.com/office/drawing/2014/main" val="1458368332"/>
+                      <a16:colId xmlns:a16="http://schemas.microsoft.com/office/drawing/2014/main" val="2522444998"/>
                     </a:ext>
                   </a:extLst>
                 </a:gridCol>
                 <a:gridCol w="3598333">
                   <a:extLst>
                     <a:ext uri="{9D8B030D-6E8A-4147-A177-3AD203B41FA5}">
-                      <a16:colId xmlns:a16="http://schemas.microsoft.com/office/drawing/2014/main" val="1911609076"/>
+                      <a16:colId xmlns:a16="http://schemas.microsoft.com/office/drawing/2014/main" val="3550611374"/>
                     </a:ext>
                   </a:extLst>
                 </a:gridCol>
                 <a:gridCol w="3598333">
                   <a:extLst>
                     <a:ext uri="{9D8B030D-6E8A-4147-A177-3AD203B41FA5}">
-                      <a16:colId xmlns:a16="http://schemas.microsoft.com/office/drawing/2014/main" val="65778958"/>
+                      <a16:colId xmlns:a16="http://schemas.microsoft.com/office/drawing/2014/main" val="3565510503"/>
                     </a:ext>
                   </a:extLst>
                 </a:gridCol>
@@ -11883,7 +11919,7 @@
                 </a:tc>
                 <a:extLst>
                   <a:ext uri="{0D108BD9-81ED-4DB2-BD59-A6C34878D82A}">
-                    <a16:rowId xmlns:a16="http://schemas.microsoft.com/office/drawing/2014/main" val="1991955759"/>
+                    <a16:rowId xmlns:a16="http://schemas.microsoft.com/office/drawing/2014/main" val="3428753548"/>
                   </a:ext>
                 </a:extLst>
               </a:tr>
@@ -11956,7 +11992,7 @@
                 </a:tc>
                 <a:extLst>
                   <a:ext uri="{0D108BD9-81ED-4DB2-BD59-A6C34878D82A}">
-                    <a16:rowId xmlns:a16="http://schemas.microsoft.com/office/drawing/2014/main" val="1562048432"/>
+                    <a16:rowId xmlns:a16="http://schemas.microsoft.com/office/drawing/2014/main" val="574721553"/>
                   </a:ext>
                 </a:extLst>
               </a:tr>
@@ -12050,7 +12086,7 @@
                 </a:tc>
                 <a:extLst>
                   <a:ext uri="{0D108BD9-81ED-4DB2-BD59-A6C34878D82A}">
-                    <a16:rowId xmlns:a16="http://schemas.microsoft.com/office/drawing/2014/main" val="1282002889"/>
+                    <a16:rowId xmlns:a16="http://schemas.microsoft.com/office/drawing/2014/main" val="188906170"/>
                   </a:ext>
                 </a:extLst>
               </a:tr>
@@ -12123,7 +12159,7 @@
                 </a:tc>
                 <a:extLst>
                   <a:ext uri="{0D108BD9-81ED-4DB2-BD59-A6C34878D82A}">
-                    <a16:rowId xmlns:a16="http://schemas.microsoft.com/office/drawing/2014/main" val="1651027476"/>
+                    <a16:rowId xmlns:a16="http://schemas.microsoft.com/office/drawing/2014/main" val="473563006"/>
                   </a:ext>
                 </a:extLst>
               </a:tr>
@@ -12196,7 +12232,7 @@
                 </a:tc>
                 <a:extLst>
                   <a:ext uri="{0D108BD9-81ED-4DB2-BD59-A6C34878D82A}">
-                    <a16:rowId xmlns:a16="http://schemas.microsoft.com/office/drawing/2014/main" val="1631174630"/>
+                    <a16:rowId xmlns:a16="http://schemas.microsoft.com/office/drawing/2014/main" val="3375094642"/>
                   </a:ext>
                 </a:extLst>
               </a:tr>
@@ -12209,7 +12245,7 @@
           <p:cNvPr id="5" name="TextBox 4">
             <a:extLst>
               <a:ext uri="{FF2B5EF4-FFF2-40B4-BE49-F238E27FC236}">
-                <a16:creationId xmlns:a16="http://schemas.microsoft.com/office/drawing/2014/main" id="{065D43EC-BF08-EA29-3512-C76EF120C93F}"/>
+                <a16:creationId xmlns:a16="http://schemas.microsoft.com/office/drawing/2014/main" id="{78010A60-8434-4B78-B72D-A069FEB253B5}"/>
               </a:ext>
             </a:extLst>
           </p:cNvPr>
@@ -12252,7 +12288,7 @@
     </p:spTree>
     <p:extLst>
       <p:ext uri="{BB962C8B-B14F-4D97-AF65-F5344CB8AC3E}">
-        <p14:creationId xmlns:p14="http://schemas.microsoft.com/office/powerpoint/2010/main" val="4075687595"/>
+        <p14:creationId xmlns:p14="http://schemas.microsoft.com/office/powerpoint/2010/main" val="216974819"/>
       </p:ext>
     </p:extLst>
   </p:cSld>
@@ -12292,7 +12328,7 @@
           <p:cNvPr id="2" name="TextBox 1">
             <a:extLst>
               <a:ext uri="{FF2B5EF4-FFF2-40B4-BE49-F238E27FC236}">
-                <a16:creationId xmlns:a16="http://schemas.microsoft.com/office/drawing/2014/main" id="{C08D90EA-D31C-267B-E741-22AE4CF01E48}"/>
+                <a16:creationId xmlns:a16="http://schemas.microsoft.com/office/drawing/2014/main" id="{98D4CFCE-E2F0-131B-6E5F-EF8570ED4B58}"/>
               </a:ext>
             </a:extLst>
           </p:cNvPr>
@@ -12337,7 +12373,7 @@
           <p:cNvPr id="3" name="TextBox 2">
             <a:extLst>
               <a:ext uri="{FF2B5EF4-FFF2-40B4-BE49-F238E27FC236}">
-                <a16:creationId xmlns:a16="http://schemas.microsoft.com/office/drawing/2014/main" id="{186A4A60-A75F-9650-C8DA-FE7DAB19893E}"/>
+                <a16:creationId xmlns:a16="http://schemas.microsoft.com/office/drawing/2014/main" id="{E5C35EF8-EF99-A882-2328-F5A619BA2A77}"/>
               </a:ext>
             </a:extLst>
           </p:cNvPr>
@@ -12382,7 +12418,7 @@
           <p:cNvPr id="4" name="TextBox 3">
             <a:extLst>
               <a:ext uri="{FF2B5EF4-FFF2-40B4-BE49-F238E27FC236}">
-                <a16:creationId xmlns:a16="http://schemas.microsoft.com/office/drawing/2014/main" id="{56D3B542-A163-095D-16B8-0F2DF884CC69}"/>
+                <a16:creationId xmlns:a16="http://schemas.microsoft.com/office/drawing/2014/main" id="{3B40BB2C-C141-355C-8022-1BC78E942040}"/>
               </a:ext>
             </a:extLst>
           </p:cNvPr>
@@ -12463,7 +12499,7 @@
           <p:cNvPr id="5" name="TextBox 4">
             <a:extLst>
               <a:ext uri="{FF2B5EF4-FFF2-40B4-BE49-F238E27FC236}">
-                <a16:creationId xmlns:a16="http://schemas.microsoft.com/office/drawing/2014/main" id="{DCC3C3F2-71EE-F996-6FC9-215D93202F39}"/>
+                <a16:creationId xmlns:a16="http://schemas.microsoft.com/office/drawing/2014/main" id="{6F6C577E-C376-8AEA-0E5B-117B6F7F46A6}"/>
               </a:ext>
             </a:extLst>
           </p:cNvPr>
@@ -12514,7 +12550,7 @@
           <p:cNvPr id="6" name="TextBox 5">
             <a:extLst>
               <a:ext uri="{FF2B5EF4-FFF2-40B4-BE49-F238E27FC236}">
-                <a16:creationId xmlns:a16="http://schemas.microsoft.com/office/drawing/2014/main" id="{6857E916-6179-5729-0E6B-6BF9AA4E5EAC}"/>
+                <a16:creationId xmlns:a16="http://schemas.microsoft.com/office/drawing/2014/main" id="{D11DB0ED-AC8D-A0F8-5916-06B3E4D7CF42}"/>
               </a:ext>
             </a:extLst>
           </p:cNvPr>
@@ -12559,7 +12595,7 @@
           <p:cNvPr id="7" name="TextBox 6">
             <a:extLst>
               <a:ext uri="{FF2B5EF4-FFF2-40B4-BE49-F238E27FC236}">
-                <a16:creationId xmlns:a16="http://schemas.microsoft.com/office/drawing/2014/main" id="{15731BE3-F4D9-0321-697E-210B4775362D}"/>
+                <a16:creationId xmlns:a16="http://schemas.microsoft.com/office/drawing/2014/main" id="{DEA23903-0A63-7D3E-A46D-C75785484176}"/>
               </a:ext>
             </a:extLst>
           </p:cNvPr>
@@ -12608,7 +12644,7 @@
     </p:spTree>
     <p:extLst>
       <p:ext uri="{BB962C8B-B14F-4D97-AF65-F5344CB8AC3E}">
-        <p14:creationId xmlns:p14="http://schemas.microsoft.com/office/powerpoint/2010/main" val="871591392"/>
+        <p14:creationId xmlns:p14="http://schemas.microsoft.com/office/powerpoint/2010/main" val="1108963003"/>
       </p:ext>
     </p:extLst>
   </p:cSld>

</xml_diff>